<commit_message>
refactor: consolidate thesis presentation by removing backup file and updating primary slide deck
</commit_message>
<xml_diff>
--- a/Thesis Defence Presentation.pptx
+++ b/Thesis Defence Presentation.pptx
@@ -16449,8 +16449,8 @@
         </p:nvSpPr>
         <p:spPr>
           <a:xfrm>
-            <a:off x="731520" y="938224"/>
-            <a:ext cx="10698480" cy="411480"/>
+            <a:off x="731520" y="1041256"/>
+            <a:ext cx="10698480" cy="400110"/>
           </a:xfrm>
           <a:prstGeom prst="rect">
             <a:avLst/>
@@ -16464,15 +16464,16 @@
           <a:lstStyle/>
           <a:p>
             <a:pPr>
-              <a:defRPr sz="1300" i="1">
-                <a:solidFill>
-                  <a:srgbClr val="505A55"/>
-                </a:solidFill>
-              </a:defRPr>
-            </a:pPr>
-            <a:r>
-              <a:rPr dirty="0"/>
-              <a:t>The corporate practice of creating a public illusion of environmental responsibility while core pollution continues behind the scenes.</a:t>
+              <a:defRPr sz="2200" b="1">
+                <a:solidFill>
+                  <a:srgbClr val="173F35"/>
+                </a:solidFill>
+                <a:latin typeface="Georgia"/>
+              </a:defRPr>
+            </a:pPr>
+            <a:r>
+              <a:rPr lang="en-IN" sz="1400" dirty="0"/>
+              <a:t>Greenwashing is any misleading, exaggerated, vague, or unsubstantiated environmental claim made by an entity.</a:t>
             </a:r>
           </a:p>
         </p:txBody>
@@ -21067,10 +21068,10 @@
               </a:defRPr>
             </a:pPr>
             <a:r>
-              <a:rPr sz="1600"/>
+              <a:rPr sz="1600" dirty="0"/>
               <a:t>Greenwashing is any misleading, exaggerated, vague, or unsubstantiated environmental claim.</a:t>
             </a:r>
-            <a:endParaRPr lang="en-US" sz="1600"/>
+            <a:endParaRPr lang="en-US" sz="1600" dirty="0"/>
           </a:p>
         </p:txBody>
       </p:sp>

</xml_diff>

<commit_message>
chore: add temporary lock file to .gitignore for thesis presentation
</commit_message>
<xml_diff>
--- a/Thesis Defence Presentation.pptx
+++ b/Thesis Defence Presentation.pptx
@@ -20311,7 +20311,7 @@
         <p:spPr>
           <a:xfrm>
             <a:off x="731520" y="1067013"/>
-            <a:ext cx="10698480" cy="457200"/>
+            <a:ext cx="10698480" cy="392415"/>
           </a:xfrm>
           <a:prstGeom prst="rect">
             <a:avLst/>
@@ -20332,8 +20332,16 @@
               </a:defRPr>
             </a:pPr>
             <a:r>
-              <a:rPr dirty="0"/>
-              <a:t>Greenwashing is not an abstract corporate crime—it directly exploits your personal goodwill, your wallet, and your family's future.</a:t>
+              <a:rPr b="1" dirty="0"/>
+              <a:t>Greenwashing is not an abstract corporate crime—it directly exploits </a:t>
+            </a:r>
+            <a:r>
+              <a:rPr lang="en-US" b="1" dirty="0"/>
+              <a:t>our</a:t>
+            </a:r>
+            <a:r>
+              <a:rPr b="1" dirty="0"/>
+              <a:t> personal goodwill, our wallet, and our family's future.</a:t>
             </a:r>
           </a:p>
         </p:txBody>
@@ -20437,7 +20445,7 @@
         <p:spPr>
           <a:xfrm>
             <a:off x="868680" y="1920240"/>
-            <a:ext cx="3108960" cy="3200400"/>
+            <a:ext cx="3108960" cy="2785378"/>
           </a:xfrm>
           <a:prstGeom prst="rect">
             <a:avLst/>
@@ -20461,7 +20469,16 @@
               </a:defRPr>
             </a:pPr>
             <a:r>
-              <a:t>💳  YOUR WALLET</a:t>
+              <a:rPr dirty="0"/>
+              <a:t>💳  </a:t>
+            </a:r>
+            <a:r>
+              <a:rPr lang="en-US" dirty="0"/>
+              <a:t>OUR</a:t>
+            </a:r>
+            <a:r>
+              <a:rPr dirty="0"/>
+              <a:t> WALLET</a:t>
             </a:r>
           </a:p>
           <a:p>
@@ -20476,7 +20493,16 @@
               </a:defRPr>
             </a:pPr>
             <a:r>
-              <a:t>"The Premium You Pay"</a:t>
+              <a:rPr sz="1600" dirty="0"/>
+              <a:t>"The Premium </a:t>
+            </a:r>
+            <a:r>
+              <a:rPr lang="en-US" sz="1600" dirty="0"/>
+              <a:t>we</a:t>
+            </a:r>
+            <a:r>
+              <a:rPr sz="1600" dirty="0"/>
+              <a:t> Pay"</a:t>
             </a:r>
           </a:p>
           <a:p>
@@ -20488,12 +20514,42 @@
               </a:defRPr>
             </a:pPr>
             <a:r>
-              <a:t>When you deliberately choose the 'eco-friendly' or 'sustainable' option on store shelves and pay extra out of your own pocket, you act with genuine goodwill.</a:t>
-            </a:r>
-            <a:br/>
-            <a:br/>
-            <a:r>
-              <a:t>Yet, your hard-earned money often ends up funding high-budget PR campaigns rather than any real environmental progress.</a:t>
+              <a:rPr sz="1400" dirty="0"/>
+              <a:t>When </a:t>
+            </a:r>
+            <a:r>
+              <a:rPr lang="en-US" sz="1400" dirty="0"/>
+              <a:t>we</a:t>
+            </a:r>
+            <a:r>
+              <a:rPr sz="1400" dirty="0"/>
+              <a:t> deliberately choose the 'eco-friendly' or 'sustainable' option on store shelves and pay extra out of </a:t>
+            </a:r>
+            <a:r>
+              <a:rPr lang="en-US" sz="1400" dirty="0"/>
+              <a:t>o</a:t>
+            </a:r>
+            <a:r>
+              <a:rPr sz="1400" dirty="0"/>
+              <a:t>ur own pocket, </a:t>
+            </a:r>
+            <a:r>
+              <a:rPr lang="en-US" sz="1400" dirty="0"/>
+              <a:t>we</a:t>
+            </a:r>
+            <a:r>
+              <a:rPr sz="1400" dirty="0"/>
+              <a:t> act with genuine goodwill.</a:t>
+            </a:r>
+            <a:br>
+              <a:rPr sz="1400" dirty="0"/>
+            </a:br>
+            <a:br>
+              <a:rPr sz="1400" dirty="0"/>
+            </a:br>
+            <a:r>
+              <a:rPr sz="1400" dirty="0"/>
+              <a:t>Yet, our hard-earned money often ends up funding high-budget PR campaigns rather than any real environmental progress.</a:t>
             </a:r>
           </a:p>
         </p:txBody>
@@ -20597,7 +20653,7 @@
         <p:spPr>
           <a:xfrm>
             <a:off x="4526280" y="1920240"/>
-            <a:ext cx="3108960" cy="3200400"/>
+            <a:ext cx="3108960" cy="2785378"/>
           </a:xfrm>
           <a:prstGeom prst="rect">
             <a:avLst/>
@@ -20621,7 +20677,16 @@
               </a:defRPr>
             </a:pPr>
             <a:r>
-              <a:t>🛡️  YOUR CHOICE</a:t>
+              <a:rPr dirty="0"/>
+              <a:t>🛡️  </a:t>
+            </a:r>
+            <a:r>
+              <a:rPr lang="en-US" dirty="0"/>
+              <a:t>OUR</a:t>
+            </a:r>
+            <a:r>
+              <a:rPr dirty="0"/>
+              <a:t> CHOICE</a:t>
             </a:r>
           </a:p>
           <a:p>
@@ -20636,6 +20701,7 @@
               </a:defRPr>
             </a:pPr>
             <a:r>
+              <a:rPr sz="1600" dirty="0"/>
               <a:t>"The Illusion of Effort"</a:t>
             </a:r>
           </a:p>
@@ -20648,12 +20714,22 @@
               </a:defRPr>
             </a:pPr>
             <a:r>
-              <a:t>You try your best in daily life—separating waste, carrying cloth bags, and choosing conscious brands.</a:t>
-            </a:r>
-            <a:br/>
-            <a:br/>
-            <a:r>
-              <a:t>Deceptive corporate claims undermine your personal efforts, turning your ethical lifestyle choices into zero-impact gestures while industrial pollution continues unchecked.</a:t>
+              <a:rPr lang="en-US" sz="1400" dirty="0"/>
+              <a:t>We</a:t>
+            </a:r>
+            <a:r>
+              <a:rPr sz="1400" dirty="0"/>
+              <a:t> try our best in daily life—separating waste, carrying cloth bags, and choosing conscious brands.</a:t>
+            </a:r>
+            <a:br>
+              <a:rPr sz="1400" dirty="0"/>
+            </a:br>
+            <a:br>
+              <a:rPr sz="1400" dirty="0"/>
+            </a:br>
+            <a:r>
+              <a:rPr sz="1400" dirty="0"/>
+              <a:t>Deceptive corporate claims undermine our personal efforts, turning our ethical lifestyle choices into zero-impact gestures while industrial pollution continues unchecked.</a:t>
             </a:r>
           </a:p>
         </p:txBody>
@@ -20757,7 +20833,7 @@
         <p:spPr>
           <a:xfrm>
             <a:off x="8183880" y="1920240"/>
-            <a:ext cx="3108960" cy="3200400"/>
+            <a:ext cx="3108960" cy="2785378"/>
           </a:xfrm>
           <a:prstGeom prst="rect">
             <a:avLst/>
@@ -20781,7 +20857,8 @@
               </a:defRPr>
             </a:pPr>
             <a:r>
-              <a:t>🌍  YOUR FUTURE</a:t>
+              <a:rPr dirty="0"/>
+              <a:t>🌍  OUR FUTURE</a:t>
             </a:r>
           </a:p>
           <a:p>
@@ -20796,6 +20873,7 @@
               </a:defRPr>
             </a:pPr>
             <a:r>
+              <a:rPr sz="1600" dirty="0"/>
               <a:t>"The Stolen Time"</a:t>
             </a:r>
           </a:p>
@@ -20808,12 +20886,34 @@
               </a:defRPr>
             </a:pPr>
             <a:r>
+              <a:rPr sz="1400" dirty="0"/>
               <a:t>Corporate 'Net-Zero by 2050' slogans create a comforting illusion that someone else is solving the climate crisis.</a:t>
             </a:r>
-            <a:br/>
-            <a:br/>
-            <a:r>
-              <a:t>This false security lulls society into inaction, while extreme weather, toxic microplastics, and environmental loss fall directly back on you and your family.</a:t>
+            <a:br>
+              <a:rPr sz="1400" dirty="0"/>
+            </a:br>
+            <a:br>
+              <a:rPr sz="1400" dirty="0"/>
+            </a:br>
+            <a:r>
+              <a:rPr sz="1400" dirty="0"/>
+              <a:t>This false security lulls society into inaction, while extreme weather, toxic microplastics, and environmental loss directly </a:t>
+            </a:r>
+            <a:r>
+              <a:rPr lang="en-US" sz="1400" dirty="0"/>
+              <a:t>affect our</a:t>
+            </a:r>
+            <a:r>
+              <a:rPr sz="1400" dirty="0"/>
+              <a:t> famil</a:t>
+            </a:r>
+            <a:r>
+              <a:rPr lang="en-US" sz="1400" dirty="0"/>
+              <a:t>ies and society</a:t>
+            </a:r>
+            <a:r>
+              <a:rPr sz="1400" dirty="0"/>
+              <a:t>.</a:t>
             </a:r>
           </a:p>
         </p:txBody>
@@ -20868,6 +20968,7 @@
               </a:defRPr>
             </a:pPr>
             <a:r>
+              <a:rPr dirty="0"/>
               <a:t>THE CONUNDRUM BEFORE US:</a:t>
             </a:r>
           </a:p>
@@ -20880,7 +20981,16 @@
               </a:defRPr>
             </a:pPr>
             <a:r>
-              <a:t>“When every label claims to be 'green', how do you protect your wallet, your trust, and your family's future?”</a:t>
+              <a:rPr dirty="0"/>
+              <a:t>“When every label claims to be 'green', how do </a:t>
+            </a:r>
+            <a:r>
+              <a:rPr lang="en-US" dirty="0"/>
+              <a:t>we</a:t>
+            </a:r>
+            <a:r>
+              <a:rPr dirty="0"/>
+              <a:t> protect our wallet, our trust and our family's future?”</a:t>
             </a:r>
           </a:p>
         </p:txBody>
@@ -20918,7 +21028,7 @@
         </p:nvSpPr>
         <p:spPr>
           <a:xfrm>
-            <a:off x="0" y="0"/>
+            <a:off x="12879" y="0"/>
             <a:ext cx="12191695" cy="6858000"/>
           </a:xfrm>
           <a:prstGeom prst="rect">
@@ -20985,8 +21095,8 @@
               </a:defRPr>
             </a:pPr>
             <a:r>
-              <a:rPr lang="en-US" sz="2800"/>
-              <a:t>What is Greenwashing and why it matters? </a:t>
+              <a:rPr lang="en-US" sz="2800" dirty="0"/>
+              <a:t>How Greenwashing evolved and why it matters? </a:t>
             </a:r>
           </a:p>
         </p:txBody>
@@ -20999,7 +21109,7 @@
         </p:nvSpPr>
         <p:spPr>
           <a:xfrm>
-            <a:off x="566928" y="1783080"/>
+            <a:off x="566928" y="2388387"/>
             <a:ext cx="5623560" cy="3584448"/>
           </a:xfrm>
           <a:prstGeom prst="roundRect">
@@ -21045,7 +21155,7 @@
         </p:nvSpPr>
         <p:spPr>
           <a:xfrm>
-            <a:off x="822960" y="2029968"/>
+            <a:off x="822960" y="2622396"/>
             <a:ext cx="5120640" cy="830997"/>
           </a:xfrm>
           <a:prstGeom prst="rect">
@@ -21083,7 +21193,7 @@
         </p:nvSpPr>
         <p:spPr>
           <a:xfrm>
-            <a:off x="951924" y="2966421"/>
+            <a:off x="951924" y="3571728"/>
             <a:ext cx="4846320" cy="1846659"/>
           </a:xfrm>
           <a:prstGeom prst="rect">
@@ -21115,7 +21225,7 @@
               <a:t>It appears across packaging, websites, advertisements, sustainability reports, BRSR filings, ESG ratings, green debt instruments, and net-zero </a:t>
             </a:r>
             <a:r>
-              <a:rPr lang="en-US"/>
+              <a:rPr lang="en-US" dirty="0"/>
               <a:t>carbon emission claims</a:t>
             </a:r>
             <a:r>
@@ -21139,6 +21249,7 @@
               </a:defRPr>
             </a:pPr>
             <a:r>
+              <a:rPr dirty="0"/>
               <a:t>The harm is not limited to consumer deception. It also distorts capital allocation, weakens market integrity, and delays climate action.</a:t>
             </a:r>
           </a:p>
@@ -21157,6 +21268,7 @@
               </a:defRPr>
             </a:pPr>
             <a:r>
+              <a:rPr dirty="0"/>
               <a:t>This thesis therefore treats greenwashing as a governance problem, not only a branding problem.</a:t>
             </a:r>
           </a:p>
@@ -21170,7 +21282,7 @@
         </p:nvSpPr>
         <p:spPr>
           <a:xfrm>
-            <a:off x="6446520" y="1783080"/>
+            <a:off x="6446520" y="2388387"/>
             <a:ext cx="5193792" cy="3584448"/>
           </a:xfrm>
           <a:prstGeom prst="roundRect">
@@ -21216,7 +21328,7 @@
         </p:nvSpPr>
         <p:spPr>
           <a:xfrm>
-            <a:off x="6640378" y="2095460"/>
+            <a:off x="6640378" y="2687888"/>
             <a:ext cx="4572000" cy="353943"/>
           </a:xfrm>
           <a:prstGeom prst="rect">
@@ -21239,7 +21351,7 @@
               </a:defRPr>
             </a:pPr>
             <a:r>
-              <a:rPr>
+              <a:rPr dirty="0">
                 <a:solidFill>
                   <a:srgbClr val="173F35"/>
                 </a:solidFill>
@@ -21247,7 +21359,7 @@
               <a:t>Why it matters</a:t>
             </a:r>
             <a:r>
-              <a:rPr lang="en-US">
+              <a:rPr lang="en-US" dirty="0">
                 <a:solidFill>
                   <a:srgbClr val="173F35"/>
                 </a:solidFill>
@@ -21265,7 +21377,7 @@
         </p:nvSpPr>
         <p:spPr>
           <a:xfrm>
-            <a:off x="6492025" y="2615184"/>
+            <a:off x="6492025" y="3220491"/>
             <a:ext cx="5151928" cy="2344616"/>
           </a:xfrm>
           <a:prstGeom prst="rect">
@@ -21531,7 +21643,7 @@
         </p:nvSpPr>
         <p:spPr>
           <a:xfrm>
-            <a:off x="566928" y="5480000"/>
+            <a:off x="566928" y="1371635"/>
             <a:ext cx="11060000" cy="850000"/>
           </a:xfrm>
           <a:prstGeom prst="roundRect">
@@ -21579,7 +21691,7 @@
         </p:nvSpPr>
         <p:spPr>
           <a:xfrm>
-            <a:off x="696928" y="5550000"/>
+            <a:off x="696928" y="1441635"/>
             <a:ext cx="10800000" cy="710000"/>
           </a:xfrm>
           <a:prstGeom prst="rect">
@@ -21599,7 +21711,7 @@
               </a:spcAft>
             </a:pPr>
             <a:r>
-              <a:rPr sz="1000" b="1" i="0">
+              <a:rPr sz="1000" b="1" i="0" dirty="0">
                 <a:solidFill>
                   <a:srgbClr val="095E4F"/>
                 </a:solidFill>
@@ -21608,19 +21720,55 @@
               <a:t>How it has evolved:  </a:t>
             </a:r>
             <a:r>
-              <a:rPr sz="1000" b="0" i="0">
+              <a:rPr sz="1000" b="0" i="0" dirty="0">
                 <a:solidFill>
                   <a:srgbClr val="3A3A4A"/>
                 </a:solidFill>
                 <a:latin typeface="Calibri"/>
               </a:rPr>
-              <a:t>a 1986 hotel towel notice → 1990s green product advertising → TerraChoice names seven recurring ‘sins’ in 2007–10 → whole-company image management → today, ESG reports, green debt and long-dated net-zero promises (‘futurewashing’).</a:t>
+              <a:t>a 1986 hotel towel notice → 1990s green product advertising → </a:t>
+            </a:r>
+            <a:r>
+              <a:rPr sz="1000" b="0" i="0" dirty="0" err="1">
+                <a:solidFill>
+                  <a:srgbClr val="3A3A4A"/>
+                </a:solidFill>
+                <a:latin typeface="Calibri"/>
+              </a:rPr>
+              <a:t>TerraChoice</a:t>
+            </a:r>
+            <a:r>
+              <a:rPr sz="1000" b="0" i="0" dirty="0">
+                <a:solidFill>
+                  <a:srgbClr val="3A3A4A"/>
+                </a:solidFill>
+                <a:latin typeface="Calibri"/>
+              </a:rPr>
+              <a:t> names seven recurring ‘sins’ in 2007–10 → whole-company image management → today, ESG reports, green debt and long-dated net-zero promises (‘</a:t>
+            </a:r>
+            <a:r>
+              <a:rPr sz="1000" b="0" i="0" dirty="0" err="1">
+                <a:solidFill>
+                  <a:srgbClr val="3A3A4A"/>
+                </a:solidFill>
+                <a:latin typeface="Calibri"/>
+              </a:rPr>
+              <a:t>futurewashing</a:t>
+            </a:r>
+            <a:r>
+              <a:rPr sz="1000" b="0" i="0" dirty="0">
+                <a:solidFill>
+                  <a:srgbClr val="3A3A4A"/>
+                </a:solidFill>
+                <a:latin typeface="Calibri"/>
+              </a:rPr>
+              <a:t>’).</a:t>
             </a:r>
           </a:p>
           <a:p>
             <a:pPr algn="l"/>
             <a:r>
-              <a:rPr sz="1000" b="1" i="0">
+              <a:rPr sz="1000" b="1" i="0" dirty="0">
                 <a:solidFill>
                   <a:srgbClr val="095E4F"/>
                 </a:solidFill>
@@ -21629,7 +21777,7 @@
               <a:t>Answer to RQ1:  </a:t>
             </a:r>
             <a:r>
-              <a:rPr sz="1000" b="0" i="0">
+              <a:rPr sz="1000" b="0" i="0" dirty="0">
                 <a:solidFill>
                   <a:srgbClr val="3A3A4A"/>
                 </a:solidFill>
@@ -21767,7 +21915,7 @@
         <p:spPr>
           <a:xfrm>
             <a:off x="548640" y="384048"/>
-            <a:ext cx="7863840" cy="640080"/>
+            <a:ext cx="7863840" cy="430887"/>
           </a:xfrm>
           <a:prstGeom prst="rect">
             <a:avLst/>
@@ -21789,7 +21937,16 @@
               </a:defRPr>
             </a:pPr>
             <a:r>
-              <a:t>The Scale of the Problem Is Already Visible in India</a:t>
+              <a:rPr dirty="0"/>
+              <a:t>The Scale of the Problem</a:t>
+            </a:r>
+            <a:r>
+              <a:rPr lang="en-US" dirty="0"/>
+              <a:t>: As </a:t>
+            </a:r>
+            <a:r>
+              <a:rPr dirty="0"/>
+              <a:t>Visible in India</a:t>
             </a:r>
           </a:p>
         </p:txBody>
@@ -22908,7 +23065,7 @@
         <p:spPr>
           <a:xfrm>
             <a:off x="566928" y="960120"/>
-            <a:ext cx="3978397" cy="276999"/>
+            <a:ext cx="4170629" cy="276999"/>
           </a:xfrm>
           <a:prstGeom prst="rect">
             <a:avLst/>
@@ -22930,14 +23087,9 @@
               </a:defRPr>
             </a:pPr>
             <a:r>
-              <a:rPr lang="en-US" dirty="0"/>
-              <a:t>Based on available data from </a:t>
-            </a:r>
-            <a:r>
-              <a:rPr lang="en-US"/>
-              <a:t>authority-based sources</a:t>
-            </a:r>
-            <a:endParaRPr lang="en-US" dirty="0"/>
+              <a:rPr lang="en-US" b="1" dirty="0"/>
+              <a:t>Based on available data from authority-based sources</a:t>
+            </a:r>
           </a:p>
         </p:txBody>
       </p:sp>

</xml_diff>

<commit_message>
docs: update slides for thesis defence presentation
</commit_message>
<xml_diff>
--- a/Thesis Defence Presentation.pptx
+++ b/Thesis Defence Presentation.pptx
@@ -5,7 +5,7 @@
     <p:sldMasterId id="2147483648" r:id="rId1"/>
   </p:sldMasterIdLst>
   <p:notesMasterIdLst>
-    <p:notesMasterId r:id="rId25"/>
+    <p:notesMasterId r:id="rId26"/>
   </p:notesMasterIdLst>
   <p:sldIdLst>
     <p:sldId id="279" r:id="rId2"/>
@@ -28,9 +28,10 @@
     <p:sldId id="262" r:id="rId19"/>
     <p:sldId id="272" r:id="rId20"/>
     <p:sldId id="296" r:id="rId21"/>
-    <p:sldId id="291" r:id="rId22"/>
-    <p:sldId id="266" r:id="rId23"/>
-    <p:sldId id="292" r:id="rId24"/>
+    <p:sldId id="299" r:id="rId22"/>
+    <p:sldId id="291" r:id="rId23"/>
+    <p:sldId id="266" r:id="rId24"/>
+    <p:sldId id="292" r:id="rId25"/>
   </p:sldIdLst>
   <p:sldSz cx="12192000" cy="6858000"/>
   <p:notesSz cx="6858000" cy="9144000"/>
@@ -238,7 +239,7 @@
           <a:p>
             <a:fld id="{5D16D8C7-7ACE-0E43-ADC6-5E8A68AC397B}" type="datetimeFigureOut">
               <a:rPr lang="en-US" smtClean="0"/>
-              <a:t>8/13/26</a:t>
+              <a:t>8/14/26</a:t>
             </a:fld>
             <a:endParaRPr lang="en-US"/>
           </a:p>
@@ -685,7 +686,7 @@
           <a:p>
             <a:fld id="{5BCAD085-E8A6-8845-BD4E-CB4CCA059FC4}" type="datetimeFigureOut">
               <a:rPr lang="en-US" smtClean="0"/>
-              <a:t>8/13/26</a:t>
+              <a:t>8/14/26</a:t>
             </a:fld>
             <a:endParaRPr lang="en-US"/>
           </a:p>
@@ -853,7 +854,7 @@
           <a:p>
             <a:fld id="{5BCAD085-E8A6-8845-BD4E-CB4CCA059FC4}" type="datetimeFigureOut">
               <a:rPr lang="en-US" smtClean="0"/>
-              <a:t>8/13/26</a:t>
+              <a:t>8/14/26</a:t>
             </a:fld>
             <a:endParaRPr lang="en-US"/>
           </a:p>
@@ -1031,7 +1032,7 @@
           <a:p>
             <a:fld id="{5BCAD085-E8A6-8845-BD4E-CB4CCA059FC4}" type="datetimeFigureOut">
               <a:rPr lang="en-US" smtClean="0"/>
-              <a:t>8/13/26</a:t>
+              <a:t>8/14/26</a:t>
             </a:fld>
             <a:endParaRPr lang="en-US"/>
           </a:p>
@@ -1199,7 +1200,7 @@
           <a:p>
             <a:fld id="{5BCAD085-E8A6-8845-BD4E-CB4CCA059FC4}" type="datetimeFigureOut">
               <a:rPr lang="en-US" smtClean="0"/>
-              <a:t>8/13/26</a:t>
+              <a:t>8/14/26</a:t>
             </a:fld>
             <a:endParaRPr lang="en-US"/>
           </a:p>
@@ -1444,7 +1445,7 @@
           <a:p>
             <a:fld id="{5BCAD085-E8A6-8845-BD4E-CB4CCA059FC4}" type="datetimeFigureOut">
               <a:rPr lang="en-US" smtClean="0"/>
-              <a:t>8/13/26</a:t>
+              <a:t>8/14/26</a:t>
             </a:fld>
             <a:endParaRPr lang="en-US"/>
           </a:p>
@@ -1729,7 +1730,7 @@
           <a:p>
             <a:fld id="{5BCAD085-E8A6-8845-BD4E-CB4CCA059FC4}" type="datetimeFigureOut">
               <a:rPr lang="en-US" smtClean="0"/>
-              <a:t>8/13/26</a:t>
+              <a:t>8/14/26</a:t>
             </a:fld>
             <a:endParaRPr lang="en-US"/>
           </a:p>
@@ -2148,7 +2149,7 @@
           <a:p>
             <a:fld id="{5BCAD085-E8A6-8845-BD4E-CB4CCA059FC4}" type="datetimeFigureOut">
               <a:rPr lang="en-US" smtClean="0"/>
-              <a:t>8/13/26</a:t>
+              <a:t>8/14/26</a:t>
             </a:fld>
             <a:endParaRPr lang="en-US"/>
           </a:p>
@@ -2265,7 +2266,7 @@
           <a:p>
             <a:fld id="{5BCAD085-E8A6-8845-BD4E-CB4CCA059FC4}" type="datetimeFigureOut">
               <a:rPr lang="en-US" smtClean="0"/>
-              <a:t>8/13/26</a:t>
+              <a:t>8/14/26</a:t>
             </a:fld>
             <a:endParaRPr lang="en-US"/>
           </a:p>
@@ -2360,7 +2361,7 @@
           <a:p>
             <a:fld id="{5BCAD085-E8A6-8845-BD4E-CB4CCA059FC4}" type="datetimeFigureOut">
               <a:rPr lang="en-US" smtClean="0"/>
-              <a:t>8/13/26</a:t>
+              <a:t>8/14/26</a:t>
             </a:fld>
             <a:endParaRPr lang="en-US"/>
           </a:p>
@@ -2635,7 +2636,7 @@
           <a:p>
             <a:fld id="{5BCAD085-E8A6-8845-BD4E-CB4CCA059FC4}" type="datetimeFigureOut">
               <a:rPr lang="en-US" smtClean="0"/>
-              <a:t>8/13/26</a:t>
+              <a:t>8/14/26</a:t>
             </a:fld>
             <a:endParaRPr lang="en-US"/>
           </a:p>
@@ -2887,7 +2888,7 @@
           <a:p>
             <a:fld id="{5BCAD085-E8A6-8845-BD4E-CB4CCA059FC4}" type="datetimeFigureOut">
               <a:rPr lang="en-US" smtClean="0"/>
-              <a:t>8/13/26</a:t>
+              <a:t>8/14/26</a:t>
             </a:fld>
             <a:endParaRPr lang="en-US"/>
           </a:p>
@@ -3098,7 +3099,7 @@
           <a:p>
             <a:fld id="{5BCAD085-E8A6-8845-BD4E-CB4CCA059FC4}" type="datetimeFigureOut">
               <a:rPr lang="en-US" smtClean="0"/>
-              <a:t>8/13/26</a:t>
+              <a:t>8/14/26</a:t>
             </a:fld>
             <a:endParaRPr lang="en-US"/>
           </a:p>
@@ -18495,7 +18496,7 @@
       </p:grpSpPr>
       <p:sp>
         <p:nvSpPr>
-          <p:cNvPr id="3" name="Rectangle 2"/>
+          <p:cNvPr id="2" name="Rectangle 1"/>
           <p:cNvSpPr/>
           <p:nvPr/>
         </p:nvSpPr>
@@ -18539,14 +18540,50 @@
       </p:sp>
       <p:sp>
         <p:nvSpPr>
+          <p:cNvPr id="3" name="TextBox 2"/>
+          <p:cNvSpPr txBox="1"/>
+          <p:nvPr/>
+        </p:nvSpPr>
+        <p:spPr>
+          <a:xfrm>
+            <a:off x="548639" y="340000"/>
+            <a:ext cx="9500000" cy="520000"/>
+          </a:xfrm>
+          <a:prstGeom prst="rect">
+            <a:avLst/>
+          </a:prstGeom>
+          <a:noFill/>
+        </p:spPr>
+        <p:txBody>
+          <a:bodyPr wrap="square" lIns="0" tIns="0" rIns="0" bIns="0">
+            <a:spAutoFit/>
+          </a:bodyPr>
+          <a:lstStyle/>
+          <a:p>
+            <a:pPr>
+              <a:defRPr sz="2500" b="1">
+                <a:solidFill>
+                  <a:srgbClr val="173F35"/>
+                </a:solidFill>
+                <a:latin typeface="Avenir Next Demi Bold"/>
+              </a:defRPr>
+            </a:pPr>
+            <a:r>
+              <a:t>Testing of Hypotheses</a:t>
+            </a:r>
+          </a:p>
+        </p:txBody>
+      </p:sp>
+      <p:sp>
+        <p:nvSpPr>
           <p:cNvPr id="4" name="TextBox 3"/>
           <p:cNvSpPr txBox="1"/>
           <p:nvPr/>
         </p:nvSpPr>
         <p:spPr>
           <a:xfrm>
-            <a:off x="548639" y="384048"/>
-            <a:ext cx="8968847" cy="584775"/>
+            <a:off x="548639" y="860000"/>
+            <a:ext cx="11094722" cy="169277"/>
           </a:xfrm>
           <a:prstGeom prst="rect">
             <a:avLst/>
@@ -18554,106 +18591,96 @@
           <a:noFill/>
         </p:spPr>
         <p:txBody>
-          <a:bodyPr wrap="square">
+          <a:bodyPr wrap="square" lIns="0" tIns="0" rIns="0" bIns="0">
             <a:spAutoFit/>
           </a:bodyPr>
           <a:lstStyle/>
           <a:p>
-            <a:pPr>
-              <a:defRPr sz="2200" b="1">
+            <a:r>
+              <a:rPr sz="1100" b="1" dirty="0">
                 <a:solidFill>
                   <a:srgbClr val="173F35"/>
                 </a:solidFill>
                 <a:latin typeface="Avenir Next Demi Bold"/>
-              </a:defRPr>
-            </a:pPr>
-            <a:r>
-              <a:rPr lang="en-US" sz="3200" dirty="0"/>
-              <a:t>General Suggestions For Regulatory Reform</a:t>
-            </a:r>
-            <a:endParaRPr sz="3200" dirty="0"/>
-          </a:p>
-        </p:txBody>
-      </p:sp>
-      <p:sp>
-        <p:nvSpPr>
-          <p:cNvPr id="5" name="TextBox 4"/>
-          <p:cNvSpPr txBox="1"/>
-          <p:nvPr/>
-        </p:nvSpPr>
-        <p:spPr>
-          <a:xfrm>
-            <a:off x="734355" y="5702107"/>
-            <a:ext cx="11000000" cy="692497"/>
-          </a:xfrm>
-          <a:prstGeom prst="rect">
-            <a:avLst/>
-          </a:prstGeom>
-          <a:noFill/>
-        </p:spPr>
-        <p:txBody>
-          <a:bodyPr wrap="square">
-            <a:spAutoFit/>
-          </a:bodyPr>
-          <a:lstStyle/>
-          <a:p>
-            <a:pPr>
-              <a:defRPr sz="1200">
+              </a:rPr>
+              <a:t>Doctrinal &amp; </a:t>
+            </a:r>
+            <a:r>
+              <a:rPr lang="en-IN" sz="1100" b="1" dirty="0">
+                <a:solidFill>
+                  <a:srgbClr val="173F35"/>
+                </a:solidFill>
+                <a:latin typeface="Avenir Next Demi Bold"/>
+              </a:rPr>
+              <a:t>Analytical </a:t>
+            </a:r>
+            <a:r>
+              <a:rPr sz="1100" b="1" dirty="0">
+                <a:solidFill>
+                  <a:srgbClr val="173F35"/>
+                </a:solidFill>
+                <a:latin typeface="Avenir Next Demi Bold"/>
+              </a:rPr>
+              <a:t>Validity-Check</a:t>
+            </a:r>
+            <a:r>
+              <a:rPr lang="en-US" sz="1100" b="1" dirty="0">
+                <a:solidFill>
+                  <a:srgbClr val="173F35"/>
+                </a:solidFill>
+                <a:latin typeface="Avenir Next Demi Bold"/>
+              </a:rPr>
+              <a:t>s</a:t>
+            </a:r>
+            <a:r>
+              <a:rPr sz="1100" b="1" dirty="0">
+                <a:solidFill>
+                  <a:srgbClr val="173F35"/>
+                </a:solidFill>
+                <a:latin typeface="Avenir Next Demi Bold"/>
+              </a:rPr>
+              <a:t>: </a:t>
+            </a:r>
+            <a:r>
+              <a:rPr sz="1100" dirty="0">
                 <a:solidFill>
                   <a:srgbClr val="6B6F6A"/>
                 </a:solidFill>
                 <a:latin typeface="Avenir Next"/>
-              </a:defRPr>
-            </a:pPr>
-            <a:r>
-              <a:rPr sz="1400" b="0" dirty="0">
+              </a:rPr>
+              <a:t>Four-step structured </a:t>
+            </a:r>
+            <a:r>
+              <a:rPr lang="en-US" sz="1100" dirty="0">
                 <a:solidFill>
                   <a:srgbClr val="6B6F6A"/>
                 </a:solidFill>
                 <a:latin typeface="Avenir Next"/>
               </a:rPr>
-              <a:t>Research Question 7 (part 1): </a:t>
-            </a:r>
-            <a:r>
-              <a:rPr lang="en-IN" sz="1400" dirty="0">
-                <a:ea typeface="+mn-lt"/>
-                <a:cs typeface="+mn-lt"/>
-              </a:rPr>
-              <a:t>What legal and policy recommendations can create an integrated liability framework that holds corporations accountable for misleading environmental claims?</a:t>
-            </a:r>
-            <a:endParaRPr lang="en-US" sz="1400" dirty="0">
-              <a:ea typeface="+mn-lt"/>
-              <a:cs typeface="+mn-lt"/>
-            </a:endParaRPr>
-          </a:p>
-          <a:p>
-            <a:pPr>
-              <a:defRPr sz="1200">
+              <a:t>validation</a:t>
+            </a:r>
+            <a:r>
+              <a:rPr sz="1100" dirty="0">
                 <a:solidFill>
                   <a:srgbClr val="6B6F6A"/>
                 </a:solidFill>
                 <a:latin typeface="Avenir Next"/>
-              </a:defRPr>
-            </a:pPr>
-            <a:endParaRPr sz="1100" b="0" dirty="0">
-              <a:solidFill>
-                <a:srgbClr val="6B6F6A"/>
-              </a:solidFill>
-              <a:latin typeface="Avenir Next"/>
-            </a:endParaRPr>
-          </a:p>
-        </p:txBody>
-      </p:sp>
-      <p:sp>
-        <p:nvSpPr>
-          <p:cNvPr id="6" name="Rounded Rectangle 5"/>
+              </a:rPr>
+              <a:t> across Conceptual Scope, Duty-Power Allocation, Enforcement Pathway, and Rival Explanations</a:t>
+            </a:r>
+          </a:p>
+        </p:txBody>
+      </p:sp>
+      <p:sp>
+        <p:nvSpPr>
+          <p:cNvPr id="5" name="Rounded Rectangle 4"/>
           <p:cNvSpPr/>
           <p:nvPr/>
         </p:nvSpPr>
         <p:spPr>
           <a:xfrm>
-            <a:off x="670473" y="1090843"/>
-            <a:ext cx="2057400" cy="2971559"/>
+            <a:off x="400433" y="1156936"/>
+            <a:ext cx="3683771" cy="4704956"/>
           </a:xfrm>
           <a:prstGeom prst="roundRect">
             <a:avLst/>
@@ -18686,22 +18713,20 @@
           <a:lstStyle/>
           <a:p>
             <a:pPr algn="ctr"/>
-            <a:endParaRPr sz="2000">
-              <a:latin typeface="Avenir Next" panose="020B0503020202020204" pitchFamily="34" charset="0"/>
-            </a:endParaRPr>
-          </a:p>
-        </p:txBody>
-      </p:sp>
-      <p:sp>
-        <p:nvSpPr>
-          <p:cNvPr id="7" name="Rectangle 6"/>
+            <a:endParaRPr/>
+          </a:p>
+        </p:txBody>
+      </p:sp>
+      <p:sp>
+        <p:nvSpPr>
+          <p:cNvPr id="6" name="Rectangle 5"/>
           <p:cNvSpPr/>
           <p:nvPr/>
         </p:nvSpPr>
         <p:spPr>
           <a:xfrm>
-            <a:off x="670473" y="1090843"/>
-            <a:ext cx="2057400" cy="89707"/>
+            <a:off x="463498" y="1156936"/>
+            <a:ext cx="3547872" cy="73152"/>
           </a:xfrm>
           <a:prstGeom prst="rect">
             <a:avLst/>
@@ -18732,8 +18757,60 @@
           <a:lstStyle/>
           <a:p>
             <a:pPr algn="ctr"/>
-            <a:endParaRPr sz="2000">
-              <a:latin typeface="Avenir Next" panose="020B0503020202020204" pitchFamily="34" charset="0"/>
+            <a:endParaRPr/>
+          </a:p>
+        </p:txBody>
+      </p:sp>
+      <p:sp>
+        <p:nvSpPr>
+          <p:cNvPr id="7" name="TextBox 6"/>
+          <p:cNvSpPr txBox="1"/>
+          <p:nvPr/>
+        </p:nvSpPr>
+        <p:spPr>
+          <a:xfrm>
+            <a:off x="653652" y="1403545"/>
+            <a:ext cx="3154654" cy="1077218"/>
+          </a:xfrm>
+          <a:prstGeom prst="rect">
+            <a:avLst/>
+          </a:prstGeom>
+          <a:noFill/>
+        </p:spPr>
+        <p:txBody>
+          <a:bodyPr wrap="square" lIns="0" tIns="0" rIns="0" bIns="0">
+            <a:spAutoFit/>
+          </a:bodyPr>
+          <a:lstStyle/>
+          <a:p>
+            <a:pPr>
+              <a:spcAft>
+                <a:spcPts val="200"/>
+              </a:spcAft>
+            </a:pPr>
+            <a:r>
+              <a:rPr sz="1400" b="1" dirty="0">
+                <a:solidFill>
+                  <a:srgbClr val="173F35"/>
+                </a:solidFill>
+                <a:latin typeface="Avenir Next Demi Bold"/>
+              </a:rPr>
+              <a:t>H₁: </a:t>
+            </a:r>
+            <a:r>
+              <a:rPr lang="en-IN" sz="1400" b="1" dirty="0">
+                <a:solidFill>
+                  <a:srgbClr val="173F35"/>
+                </a:solidFill>
+                <a:latin typeface="Avenir Next Demi Bold"/>
+              </a:rPr>
+              <a:t>Greenwashing in India is primarily a consequence of weak corporate governance and the limited operationalisation of board-level environmental responsibility."</a:t>
+            </a:r>
+            <a:endParaRPr sz="1100" b="1" dirty="0">
+              <a:solidFill>
+                <a:srgbClr val="173F35"/>
+              </a:solidFill>
+              <a:latin typeface="Avenir Next Demi Bold"/>
             </a:endParaRPr>
           </a:p>
         </p:txBody>
@@ -18746,8 +18823,8 @@
         </p:nvSpPr>
         <p:spPr>
           <a:xfrm>
-            <a:off x="816777" y="1218860"/>
-            <a:ext cx="1764792" cy="584775"/>
+            <a:off x="653650" y="2685791"/>
+            <a:ext cx="3154654" cy="3036216"/>
           </a:xfrm>
           <a:prstGeom prst="rect">
             <a:avLst/>
@@ -18755,89 +18832,152 @@
           <a:noFill/>
         </p:spPr>
         <p:txBody>
-          <a:bodyPr wrap="square" anchor="t">
+          <a:bodyPr wrap="square" lIns="0" tIns="0" rIns="0" bIns="0">
             <a:spAutoFit/>
           </a:bodyPr>
           <a:lstStyle/>
           <a:p>
-            <a:pPr algn="l">
-              <a:defRPr sz="1600" b="1">
+            <a:pPr>
+              <a:lnSpc>
+                <a:spcPct val="105000"/>
+              </a:lnSpc>
+              <a:spcAft>
+                <a:spcPts val="500"/>
+              </a:spcAft>
+            </a:pPr>
+            <a:r>
+              <a:rPr sz="1100" b="1" dirty="0">
                 <a:solidFill>
                   <a:srgbClr val="173F35"/>
                 </a:solidFill>
-                <a:latin typeface="Avenir Next Demi Bold"/>
-              </a:defRPr>
-            </a:pPr>
-            <a:r>
-              <a:rPr>
-                <a:latin typeface="Avenir Next" panose="020B0503020202020204" pitchFamily="34" charset="0"/>
-              </a:rPr>
-              <a:t>1. Institutional integration</a:t>
-            </a:r>
-          </a:p>
-        </p:txBody>
-      </p:sp>
-      <p:sp>
-        <p:nvSpPr>
-          <p:cNvPr id="9" name="TextBox 8"/>
-          <p:cNvSpPr txBox="1"/>
-          <p:nvPr/>
-        </p:nvSpPr>
-        <p:spPr>
-          <a:xfrm>
-            <a:off x="816777" y="1730924"/>
-            <a:ext cx="1764792" cy="2031325"/>
-          </a:xfrm>
-          <a:prstGeom prst="rect">
-            <a:avLst/>
-          </a:prstGeom>
-          <a:noFill/>
-        </p:spPr>
-        <p:txBody>
-          <a:bodyPr wrap="square" anchor="t">
-            <a:spAutoFit/>
-          </a:bodyPr>
-          <a:lstStyle/>
-          <a:p>
-            <a:pPr algn="l">
-              <a:defRPr sz="1200" b="0">
+                <a:latin typeface="Avenir Next" panose="020B0503020202020204" pitchFamily="34" charset="0"/>
+              </a:rPr>
+              <a:t>1. Conceptual Scope: </a:t>
+            </a:r>
+            <a:r>
+              <a:rPr sz="1100" dirty="0">
                 <a:solidFill>
                   <a:srgbClr val="2A2A2A"/>
                 </a:solidFill>
-                <a:latin typeface="Avenir Next"/>
-              </a:defRPr>
-            </a:pPr>
-            <a:r>
-              <a:rPr sz="1400" dirty="0">
-                <a:latin typeface="Avenir Next" panose="020B0503020202020204" pitchFamily="34" charset="0"/>
-              </a:rPr>
-              <a:t>Create a permanent inter-regulatory greenwashing mechanism linking MCA, SEBI, CCPA, </a:t>
-            </a:r>
-            <a:r>
-              <a:rPr sz="1400" dirty="0" err="1">
-                <a:latin typeface="Avenir Next" panose="020B0503020202020204" pitchFamily="34" charset="0"/>
-              </a:rPr>
-              <a:t>MoEFCC</a:t>
-            </a:r>
-            <a:r>
-              <a:rPr sz="1400" dirty="0">
-                <a:latin typeface="Avenir Next" panose="020B0503020202020204" pitchFamily="34" charset="0"/>
-              </a:rPr>
-              <a:t>, CPCB, BIS, FSSAI, and sectoral bodies.</a:t>
-            </a:r>
-          </a:p>
-        </p:txBody>
-      </p:sp>
-      <p:sp>
-        <p:nvSpPr>
-          <p:cNvPr id="10" name="Rounded Rectangle 9"/>
+                <a:latin typeface="Avenir Next" panose="020B0503020202020204" pitchFamily="34" charset="0"/>
+              </a:rPr>
+              <a:t>Extends beyond consumer ads to investor-facing disclosures (sustainability reports, BRSR, net-zero/transition narratives, </a:t>
+            </a:r>
+            <a:r>
+              <a:rPr sz="1100" dirty="0" err="1">
+                <a:solidFill>
+                  <a:srgbClr val="2A2A2A"/>
+                </a:solidFill>
+                <a:latin typeface="Avenir Next" panose="020B0503020202020204" pitchFamily="34" charset="0"/>
+              </a:rPr>
+              <a:t>futurewashing</a:t>
+            </a:r>
+            <a:r>
+              <a:rPr sz="1100" dirty="0">
+                <a:solidFill>
+                  <a:srgbClr val="2A2A2A"/>
+                </a:solidFill>
+                <a:latin typeface="Avenir Next" panose="020B0503020202020204" pitchFamily="34" charset="0"/>
+              </a:rPr>
+              <a:t>).</a:t>
+            </a:r>
+          </a:p>
+          <a:p>
+            <a:pPr>
+              <a:lnSpc>
+                <a:spcPct val="105000"/>
+              </a:lnSpc>
+              <a:spcAft>
+                <a:spcPts val="500"/>
+              </a:spcAft>
+            </a:pPr>
+            <a:r>
+              <a:rPr sz="1100" b="1" dirty="0">
+                <a:solidFill>
+                  <a:srgbClr val="173F35"/>
+                </a:solidFill>
+                <a:latin typeface="Avenir Next" panose="020B0503020202020204" pitchFamily="34" charset="0"/>
+              </a:rPr>
+              <a:t>2. Duty Allocation: </a:t>
+            </a:r>
+            <a:r>
+              <a:rPr sz="1100" dirty="0">
+                <a:solidFill>
+                  <a:srgbClr val="2A2A2A"/>
+                </a:solidFill>
+                <a:latin typeface="Avenir Next" panose="020B0503020202020204" pitchFamily="34" charset="0"/>
+              </a:rPr>
+              <a:t>Consumer law (CPA/ASCI) regulates ads without transferring onus to board decision-makers. Corporate governance is the proper locus for oversight.</a:t>
+            </a:r>
+          </a:p>
+          <a:p>
+            <a:pPr>
+              <a:lnSpc>
+                <a:spcPct val="105000"/>
+              </a:lnSpc>
+              <a:spcAft>
+                <a:spcPts val="500"/>
+              </a:spcAft>
+            </a:pPr>
+            <a:r>
+              <a:rPr sz="1100" b="1" dirty="0">
+                <a:solidFill>
+                  <a:srgbClr val="173F35"/>
+                </a:solidFill>
+                <a:latin typeface="Avenir Next" panose="020B0503020202020204" pitchFamily="34" charset="0"/>
+              </a:rPr>
+              <a:t>3. Enforcement Pathway: </a:t>
+            </a:r>
+            <a:r>
+              <a:rPr sz="1100" dirty="0">
+                <a:solidFill>
+                  <a:srgbClr val="2A2A2A"/>
+                </a:solidFill>
+                <a:latin typeface="Avenir Next" panose="020B0503020202020204" pitchFamily="34" charset="0"/>
+              </a:rPr>
+              <a:t>Consumer regime is reactive &amp; complaint-driven; corporate/securities pathways better reach upstream governance (board oversight, internal controls, assurance).</a:t>
+            </a:r>
+          </a:p>
+          <a:p>
+            <a:pPr>
+              <a:lnSpc>
+                <a:spcPct val="105000"/>
+              </a:lnSpc>
+              <a:spcAft>
+                <a:spcPts val="500"/>
+              </a:spcAft>
+            </a:pPr>
+            <a:r>
+              <a:rPr sz="1100" b="1" dirty="0">
+                <a:solidFill>
+                  <a:srgbClr val="173F35"/>
+                </a:solidFill>
+                <a:latin typeface="Avenir Next" panose="020B0503020202020204" pitchFamily="34" charset="0"/>
+              </a:rPr>
+              <a:t>4. Rival Explanation: </a:t>
+            </a:r>
+            <a:r>
+              <a:rPr sz="1100" dirty="0">
+                <a:solidFill>
+                  <a:srgbClr val="2A2A2A"/>
+                </a:solidFill>
+                <a:latin typeface="Avenir Next" panose="020B0503020202020204" pitchFamily="34" charset="0"/>
+              </a:rPr>
+              <a:t>MCA/SEBI possess misstatement powers, but the corporate governance framework for greenwashing remains jurisprudentially underdeveloped.</a:t>
+            </a:r>
+          </a:p>
+        </p:txBody>
+      </p:sp>
+      <p:sp>
+        <p:nvSpPr>
+          <p:cNvPr id="9" name="Rounded Rectangle 8"/>
           <p:cNvSpPr/>
           <p:nvPr/>
         </p:nvSpPr>
         <p:spPr>
           <a:xfrm>
-            <a:off x="2810169" y="1090843"/>
-            <a:ext cx="2057400" cy="2971559"/>
+            <a:off x="4356643" y="1156936"/>
+            <a:ext cx="3683771" cy="4704956"/>
           </a:xfrm>
           <a:prstGeom prst="roundRect">
             <a:avLst/>
@@ -18870,22 +19010,20 @@
           <a:lstStyle/>
           <a:p>
             <a:pPr algn="ctr"/>
-            <a:endParaRPr sz="2000">
-              <a:latin typeface="Avenir Next" panose="020B0503020202020204" pitchFamily="34" charset="0"/>
-            </a:endParaRPr>
-          </a:p>
-        </p:txBody>
-      </p:sp>
-      <p:sp>
-        <p:nvSpPr>
-          <p:cNvPr id="11" name="Rectangle 10"/>
+            <a:endParaRPr/>
+          </a:p>
+        </p:txBody>
+      </p:sp>
+      <p:sp>
+        <p:nvSpPr>
+          <p:cNvPr id="10" name="Rectangle 9"/>
           <p:cNvSpPr/>
           <p:nvPr/>
         </p:nvSpPr>
         <p:spPr>
           <a:xfrm>
-            <a:off x="2810169" y="1090843"/>
-            <a:ext cx="2057400" cy="89707"/>
+            <a:off x="4325112" y="1156936"/>
+            <a:ext cx="3547872" cy="73152"/>
           </a:xfrm>
           <a:prstGeom prst="rect">
             <a:avLst/>
@@ -18916,8 +19054,76 @@
           <a:lstStyle/>
           <a:p>
             <a:pPr algn="ctr"/>
-            <a:endParaRPr sz="2000">
-              <a:latin typeface="Avenir Next" panose="020B0503020202020204" pitchFamily="34" charset="0"/>
+            <a:endParaRPr/>
+          </a:p>
+        </p:txBody>
+      </p:sp>
+      <p:sp>
+        <p:nvSpPr>
+          <p:cNvPr id="11" name="TextBox 10"/>
+          <p:cNvSpPr txBox="1"/>
+          <p:nvPr/>
+        </p:nvSpPr>
+        <p:spPr>
+          <a:xfrm>
+            <a:off x="4609862" y="1403545"/>
+            <a:ext cx="3154654" cy="1464503"/>
+          </a:xfrm>
+          <a:prstGeom prst="rect">
+            <a:avLst/>
+          </a:prstGeom>
+          <a:noFill/>
+        </p:spPr>
+        <p:txBody>
+          <a:bodyPr wrap="square" lIns="0" tIns="0" rIns="0" bIns="0">
+            <a:spAutoFit/>
+          </a:bodyPr>
+          <a:lstStyle/>
+          <a:p>
+            <a:pPr>
+              <a:spcAft>
+                <a:spcPts val="200"/>
+              </a:spcAft>
+            </a:pPr>
+            <a:r>
+              <a:rPr sz="1400" b="1" dirty="0">
+                <a:solidFill>
+                  <a:srgbClr val="173F35"/>
+                </a:solidFill>
+                <a:latin typeface="Avenir Next Demi Bold"/>
+              </a:rPr>
+              <a:t>H₂:</a:t>
+            </a:r>
+            <a:r>
+              <a:rPr lang="en-US" sz="1400" b="1" dirty="0">
+                <a:solidFill>
+                  <a:srgbClr val="173F35"/>
+                </a:solidFill>
+                <a:latin typeface="Avenir Next Demi Bold"/>
+              </a:rPr>
+              <a:t> </a:t>
+            </a:r>
+            <a:r>
+              <a:rPr lang="en-IN" sz="1400" b="1" dirty="0">
+                <a:solidFill>
+                  <a:srgbClr val="173F35"/>
+                </a:solidFill>
+                <a:latin typeface="Avenir Next Demi Bold"/>
+              </a:rPr>
+              <a:t>The existing legal framework does not impose sufficiently clear, stringent, and deterrent liability for misleading environmental disclosures, thereby enabling corporations to avoid meaningful accountability.</a:t>
+            </a:r>
+          </a:p>
+          <a:p>
+            <a:pPr>
+              <a:spcAft>
+                <a:spcPts val="200"/>
+              </a:spcAft>
+            </a:pPr>
+            <a:endParaRPr sz="950" i="1" dirty="0">
+              <a:solidFill>
+                <a:srgbClr val="3A3A4A"/>
+              </a:solidFill>
+              <a:latin typeface="Avenir Next"/>
             </a:endParaRPr>
           </a:p>
         </p:txBody>
@@ -18930,8 +19136,8 @@
         </p:nvSpPr>
         <p:spPr>
           <a:xfrm>
-            <a:off x="2956473" y="1218860"/>
-            <a:ext cx="1764792" cy="830997"/>
+            <a:off x="4609862" y="2796153"/>
+            <a:ext cx="3263122" cy="3036216"/>
           </a:xfrm>
           <a:prstGeom prst="rect">
             <a:avLst/>
@@ -18939,77 +19145,152 @@
           <a:noFill/>
         </p:spPr>
         <p:txBody>
-          <a:bodyPr wrap="square" anchor="t">
+          <a:bodyPr wrap="square" lIns="0" tIns="0" rIns="0" bIns="0">
             <a:spAutoFit/>
           </a:bodyPr>
           <a:lstStyle/>
           <a:p>
-            <a:pPr algn="l">
-              <a:defRPr sz="1600" b="1">
+            <a:pPr>
+              <a:lnSpc>
+                <a:spcPct val="105000"/>
+              </a:lnSpc>
+              <a:spcAft>
+                <a:spcPts val="500"/>
+              </a:spcAft>
+            </a:pPr>
+            <a:r>
+              <a:rPr sz="1100" b="1" dirty="0">
                 <a:solidFill>
                   <a:srgbClr val="173F35"/>
                 </a:solidFill>
-                <a:latin typeface="Avenir Next Demi Bold"/>
-              </a:defRPr>
-            </a:pPr>
-            <a:r>
-              <a:rPr dirty="0">
-                <a:latin typeface="Avenir Next" panose="020B0503020202020204" pitchFamily="34" charset="0"/>
-              </a:rPr>
-              <a:t>2. Lead regulator model</a:t>
-            </a:r>
-          </a:p>
-        </p:txBody>
-      </p:sp>
-      <p:sp>
-        <p:nvSpPr>
-          <p:cNvPr id="13" name="TextBox 12"/>
-          <p:cNvSpPr txBox="1"/>
-          <p:nvPr/>
-        </p:nvSpPr>
-        <p:spPr>
-          <a:xfrm>
-            <a:off x="2956473" y="1730924"/>
-            <a:ext cx="1764792" cy="1815882"/>
-          </a:xfrm>
-          <a:prstGeom prst="rect">
-            <a:avLst/>
-          </a:prstGeom>
-          <a:noFill/>
-        </p:spPr>
-        <p:txBody>
-          <a:bodyPr wrap="square" anchor="t">
-            <a:spAutoFit/>
-          </a:bodyPr>
-          <a:lstStyle/>
-          <a:p>
-            <a:pPr algn="l">
-              <a:defRPr sz="1200" b="0">
+                <a:latin typeface="Avenir Next" panose="020B0503020202020204" pitchFamily="34" charset="0"/>
+              </a:rPr>
+              <a:t>1. Conceptual Scope: </a:t>
+            </a:r>
+            <a:r>
+              <a:rPr sz="1100" dirty="0">
                 <a:solidFill>
                   <a:srgbClr val="2A2A2A"/>
                 </a:solidFill>
-                <a:latin typeface="Avenir Next"/>
-              </a:defRPr>
-            </a:pPr>
-            <a:r>
-              <a:rPr sz="1400" dirty="0">
-                <a:latin typeface="Avenir Next" panose="020B0503020202020204" pitchFamily="34" charset="0"/>
-              </a:rPr>
-              <a:t>Use mandatory cross-referrals, shared evidence protocols, and a rule for who coordinates a claim that travels across the market.</a:t>
-            </a:r>
-          </a:p>
-        </p:txBody>
-      </p:sp>
-      <p:sp>
-        <p:nvSpPr>
-          <p:cNvPr id="14" name="Rounded Rectangle 13"/>
+                <a:latin typeface="Avenir Next" panose="020B0503020202020204" pitchFamily="34" charset="0"/>
+              </a:rPr>
+              <a:t>Tests whether legal costs exceed benefits across all 3 pillars (Company Law, Securities Law, Consumer Protection) rather than just ad fines.</a:t>
+            </a:r>
+          </a:p>
+          <a:p>
+            <a:pPr>
+              <a:lnSpc>
+                <a:spcPct val="105000"/>
+              </a:lnSpc>
+              <a:spcAft>
+                <a:spcPts val="500"/>
+              </a:spcAft>
+            </a:pPr>
+            <a:r>
+              <a:rPr sz="1100" b="1" dirty="0">
+                <a:solidFill>
+                  <a:srgbClr val="173F35"/>
+                </a:solidFill>
+                <a:latin typeface="Avenir Next" panose="020B0503020202020204" pitchFamily="34" charset="0"/>
+              </a:rPr>
+              <a:t>2. Duty Allocation: </a:t>
+            </a:r>
+            <a:r>
+              <a:rPr sz="1100" dirty="0">
+                <a:solidFill>
+                  <a:srgbClr val="2A2A2A"/>
+                </a:solidFill>
+                <a:latin typeface="Avenir Next" panose="020B0503020202020204" pitchFamily="34" charset="0"/>
+              </a:rPr>
+              <a:t>Duties exist, but ordinary liability routes are weak. § 166(2) lacks open standing (narrow §§ 241-244 route); consumer penalties (₹5L cap) lack deterrence.</a:t>
+            </a:r>
+          </a:p>
+          <a:p>
+            <a:pPr>
+              <a:lnSpc>
+                <a:spcPct val="105000"/>
+              </a:lnSpc>
+              <a:spcAft>
+                <a:spcPts val="500"/>
+              </a:spcAft>
+            </a:pPr>
+            <a:r>
+              <a:rPr sz="1100" b="1" dirty="0">
+                <a:solidFill>
+                  <a:srgbClr val="173F35"/>
+                </a:solidFill>
+                <a:latin typeface="Avenir Next" panose="020B0503020202020204" pitchFamily="34" charset="0"/>
+              </a:rPr>
+              <a:t>3. Enforcement Pathway: </a:t>
+            </a:r>
+            <a:r>
+              <a:rPr sz="1100" dirty="0">
+                <a:solidFill>
+                  <a:srgbClr val="2A2A2A"/>
+                </a:solidFill>
+                <a:latin typeface="Avenir Next" panose="020B0503020202020204" pitchFamily="34" charset="0"/>
+              </a:rPr>
+              <a:t>Detection is fragmented; weak verification raises proof burdens. </a:t>
+            </a:r>
+            <a:r>
+              <a:rPr sz="1100" dirty="0" err="1">
+                <a:solidFill>
+                  <a:srgbClr val="2A2A2A"/>
+                </a:solidFill>
+                <a:latin typeface="Avenir Next" panose="020B0503020202020204" pitchFamily="34" charset="0"/>
+              </a:rPr>
+              <a:t>Hohfeldian</a:t>
+            </a:r>
+            <a:r>
+              <a:rPr sz="1100" dirty="0">
+                <a:solidFill>
+                  <a:srgbClr val="2A2A2A"/>
+                </a:solidFill>
+                <a:latin typeface="Avenir Next" panose="020B0503020202020204" pitchFamily="34" charset="0"/>
+              </a:rPr>
+              <a:t> analysis: legal duties without accessible triggers fail to create real liability.</a:t>
+            </a:r>
+          </a:p>
+          <a:p>
+            <a:pPr>
+              <a:lnSpc>
+                <a:spcPct val="105000"/>
+              </a:lnSpc>
+              <a:spcAft>
+                <a:spcPts val="500"/>
+              </a:spcAft>
+            </a:pPr>
+            <a:r>
+              <a:rPr sz="1100" b="1" dirty="0">
+                <a:solidFill>
+                  <a:srgbClr val="173F35"/>
+                </a:solidFill>
+                <a:latin typeface="Avenir Next" panose="020B0503020202020204" pitchFamily="34" charset="0"/>
+              </a:rPr>
+              <a:t>4. Rival Explanation: </a:t>
+            </a:r>
+            <a:r>
+              <a:rPr sz="1100" dirty="0">
+                <a:solidFill>
+                  <a:srgbClr val="2A2A2A"/>
+                </a:solidFill>
+                <a:latin typeface="Avenir Next" panose="020B0503020202020204" pitchFamily="34" charset="0"/>
+              </a:rPr>
+              <a:t>Fraud provisions exist at margins, but are scattered across pillars, face high proof burdens, and lack a routine enforcement pathway.</a:t>
+            </a:r>
+          </a:p>
+        </p:txBody>
+      </p:sp>
+      <p:sp>
+        <p:nvSpPr>
+          <p:cNvPr id="13" name="Rounded Rectangle 12"/>
           <p:cNvSpPr/>
           <p:nvPr/>
         </p:nvSpPr>
         <p:spPr>
           <a:xfrm>
-            <a:off x="4949865" y="1090843"/>
-            <a:ext cx="2057400" cy="2971559"/>
+            <a:off x="8281316" y="1156936"/>
+            <a:ext cx="3683771" cy="4704956"/>
           </a:xfrm>
           <a:prstGeom prst="roundRect">
             <a:avLst/>
@@ -19042,22 +19323,20 @@
           <a:lstStyle/>
           <a:p>
             <a:pPr algn="ctr"/>
-            <a:endParaRPr sz="2000">
-              <a:latin typeface="Avenir Next" panose="020B0503020202020204" pitchFamily="34" charset="0"/>
-            </a:endParaRPr>
-          </a:p>
-        </p:txBody>
-      </p:sp>
-      <p:sp>
-        <p:nvSpPr>
-          <p:cNvPr id="15" name="Rectangle 14"/>
+            <a:endParaRPr/>
+          </a:p>
+        </p:txBody>
+      </p:sp>
+      <p:sp>
+        <p:nvSpPr>
+          <p:cNvPr id="14" name="Rectangle 13"/>
           <p:cNvSpPr/>
           <p:nvPr/>
         </p:nvSpPr>
         <p:spPr>
           <a:xfrm>
-            <a:off x="4949865" y="1090843"/>
-            <a:ext cx="2057400" cy="89707"/>
+            <a:off x="8281317" y="1156936"/>
+            <a:ext cx="3547872" cy="73152"/>
           </a:xfrm>
           <a:prstGeom prst="rect">
             <a:avLst/>
@@ -19088,9 +19367,50 @@
           <a:lstStyle/>
           <a:p>
             <a:pPr algn="ctr"/>
-            <a:endParaRPr sz="2000">
-              <a:latin typeface="Avenir Next" panose="020B0503020202020204" pitchFamily="34" charset="0"/>
-            </a:endParaRPr>
+            <a:endParaRPr/>
+          </a:p>
+        </p:txBody>
+      </p:sp>
+      <p:sp>
+        <p:nvSpPr>
+          <p:cNvPr id="15" name="TextBox 14"/>
+          <p:cNvSpPr txBox="1"/>
+          <p:nvPr/>
+        </p:nvSpPr>
+        <p:spPr>
+          <a:xfrm>
+            <a:off x="8534535" y="1403545"/>
+            <a:ext cx="3154654" cy="1077218"/>
+          </a:xfrm>
+          <a:prstGeom prst="rect">
+            <a:avLst/>
+          </a:prstGeom>
+          <a:noFill/>
+        </p:spPr>
+        <p:txBody>
+          <a:bodyPr wrap="square" lIns="0" tIns="0" rIns="0" bIns="0">
+            <a:spAutoFit/>
+          </a:bodyPr>
+          <a:lstStyle/>
+          <a:p>
+            <a:r>
+              <a:rPr sz="1400" b="1" dirty="0">
+                <a:solidFill>
+                  <a:srgbClr val="173F35"/>
+                </a:solidFill>
+                <a:latin typeface="Avenir Next Demi Bold"/>
+              </a:rPr>
+              <a:t>H₃: </a:t>
+            </a:r>
+            <a:r>
+              <a:rPr lang="en-IN" sz="1400" b="1" dirty="0">
+                <a:solidFill>
+                  <a:srgbClr val="173F35"/>
+                </a:solidFill>
+                <a:latin typeface="Avenir Next Demi Bold"/>
+              </a:rPr>
+              <a:t>In addressing the issue of greenwashing, the present legal mechanism involving different regulatory bodies is inchoate and incomplete.</a:t>
+            </a:r>
           </a:p>
         </p:txBody>
       </p:sp>
@@ -19102,8 +19422,8 @@
         </p:nvSpPr>
         <p:spPr>
           <a:xfrm>
-            <a:off x="5096169" y="1218860"/>
-            <a:ext cx="1764792" cy="584775"/>
+            <a:off x="8534535" y="2685791"/>
+            <a:ext cx="3257032" cy="3036216"/>
           </a:xfrm>
           <a:prstGeom prst="rect">
             <a:avLst/>
@@ -19111,421 +19431,152 @@
           <a:noFill/>
         </p:spPr>
         <p:txBody>
-          <a:bodyPr wrap="square" anchor="t">
+          <a:bodyPr wrap="square" lIns="0" tIns="0" rIns="0" bIns="0">
             <a:spAutoFit/>
           </a:bodyPr>
           <a:lstStyle/>
           <a:p>
-            <a:pPr algn="l">
-              <a:defRPr sz="1600" b="1">
+            <a:pPr>
+              <a:lnSpc>
+                <a:spcPct val="105000"/>
+              </a:lnSpc>
+              <a:spcAft>
+                <a:spcPts val="500"/>
+              </a:spcAft>
+            </a:pPr>
+            <a:r>
+              <a:rPr sz="1100" b="1" dirty="0">
                 <a:solidFill>
                   <a:srgbClr val="173F35"/>
                 </a:solidFill>
-                <a:latin typeface="Avenir Next Demi Bold"/>
-              </a:defRPr>
-            </a:pPr>
-            <a:r>
-              <a:rPr>
-                <a:latin typeface="Avenir Next" panose="020B0503020202020204" pitchFamily="34" charset="0"/>
-              </a:rPr>
-              <a:t>3. Standardised substantiation</a:t>
-            </a:r>
-          </a:p>
-        </p:txBody>
-      </p:sp>
-      <p:sp>
-        <p:nvSpPr>
-          <p:cNvPr id="17" name="TextBox 16"/>
-          <p:cNvSpPr txBox="1"/>
-          <p:nvPr/>
-        </p:nvSpPr>
-        <p:spPr>
-          <a:xfrm>
-            <a:off x="5096169" y="1758356"/>
-            <a:ext cx="1764792" cy="2031325"/>
-          </a:xfrm>
-          <a:prstGeom prst="rect">
-            <a:avLst/>
-          </a:prstGeom>
-          <a:noFill/>
-        </p:spPr>
-        <p:txBody>
-          <a:bodyPr wrap="square" anchor="t">
-            <a:spAutoFit/>
-          </a:bodyPr>
-          <a:lstStyle/>
-          <a:p>
-            <a:pPr algn="l">
-              <a:defRPr sz="1200" b="0">
+                <a:latin typeface="Avenir Next" panose="020B0503020202020204" pitchFamily="34" charset="0"/>
+              </a:rPr>
+              <a:t>1. Conceptual Scope: </a:t>
+            </a:r>
+            <a:r>
+              <a:rPr sz="1100" dirty="0">
                 <a:solidFill>
                   <a:srgbClr val="2A2A2A"/>
                 </a:solidFill>
-                <a:latin typeface="Avenir Next"/>
-              </a:defRPr>
-            </a:pPr>
-            <a:r>
-              <a:rPr sz="1400" dirty="0">
-                <a:latin typeface="Avenir Next" panose="020B0503020202020204" pitchFamily="34" charset="0"/>
-              </a:rPr>
-              <a:t>Move toward lifecycle-based verification, product-category rules, accredited verifiers, and common evidentiary standards.</a:t>
-            </a:r>
-          </a:p>
-        </p:txBody>
-      </p:sp>
-      <p:sp>
-        <p:nvSpPr>
-          <p:cNvPr id="18" name="Rounded Rectangle 17"/>
+                <a:latin typeface="Avenir Next" panose="020B0503020202020204" pitchFamily="34" charset="0"/>
+              </a:rPr>
+              <a:t>Greenwashing is a lifecycle phenomenon crossing products, ads, annual reports, ESG filings, and green finance instruments.</a:t>
+            </a:r>
+          </a:p>
+          <a:p>
+            <a:pPr>
+              <a:lnSpc>
+                <a:spcPct val="105000"/>
+              </a:lnSpc>
+              <a:spcAft>
+                <a:spcPts val="500"/>
+              </a:spcAft>
+            </a:pPr>
+            <a:r>
+              <a:rPr sz="1100" b="1" dirty="0">
+                <a:solidFill>
+                  <a:srgbClr val="173F35"/>
+                </a:solidFill>
+                <a:latin typeface="Avenir Next" panose="020B0503020202020204" pitchFamily="34" charset="0"/>
+              </a:rPr>
+              <a:t>2. Duty Allocation: </a:t>
+            </a:r>
+            <a:r>
+              <a:rPr sz="1100" dirty="0">
+                <a:solidFill>
+                  <a:srgbClr val="2A2A2A"/>
+                </a:solidFill>
+                <a:latin typeface="Avenir Next" panose="020B0503020202020204" pitchFamily="34" charset="0"/>
+              </a:rPr>
+              <a:t>Multi-pillar allocation creates 'lifecycle gaps': identical claims face fragmented treatment and divergent evidentiary standards across venues.</a:t>
+            </a:r>
+          </a:p>
+          <a:p>
+            <a:pPr>
+              <a:lnSpc>
+                <a:spcPct val="105000"/>
+              </a:lnSpc>
+              <a:spcAft>
+                <a:spcPts val="500"/>
+              </a:spcAft>
+            </a:pPr>
+            <a:r>
+              <a:rPr sz="1100" b="1" dirty="0">
+                <a:solidFill>
+                  <a:srgbClr val="173F35"/>
+                </a:solidFill>
+                <a:latin typeface="Avenir Next" panose="020B0503020202020204" pitchFamily="34" charset="0"/>
+              </a:rPr>
+              <a:t>3. Enforcement Pathway: </a:t>
+            </a:r>
+            <a:r>
+              <a:rPr sz="1100" dirty="0">
+                <a:solidFill>
+                  <a:srgbClr val="2A2A2A"/>
+                </a:solidFill>
+                <a:latin typeface="Avenir Next" panose="020B0503020202020204" pitchFamily="34" charset="0"/>
+              </a:rPr>
+              <a:t>Architecture lacks lead-regulator designation, mandatory cross-referrals, joint investigation protocols, and shared verification baselines.</a:t>
+            </a:r>
+          </a:p>
+          <a:p>
+            <a:pPr>
+              <a:lnSpc>
+                <a:spcPct val="105000"/>
+              </a:lnSpc>
+              <a:spcAft>
+                <a:spcPts val="500"/>
+              </a:spcAft>
+            </a:pPr>
+            <a:r>
+              <a:rPr sz="1100" b="1" dirty="0">
+                <a:solidFill>
+                  <a:srgbClr val="173F35"/>
+                </a:solidFill>
+                <a:latin typeface="Avenir Next" panose="020B0503020202020204" pitchFamily="34" charset="0"/>
+              </a:rPr>
+              <a:t>4. Rival Explanation: </a:t>
+            </a:r>
+            <a:r>
+              <a:rPr sz="1100" dirty="0">
+                <a:solidFill>
+                  <a:srgbClr val="2A2A2A"/>
+                </a:solidFill>
+                <a:latin typeface="Avenir Next" panose="020B0503020202020204" pitchFamily="34" charset="0"/>
+              </a:rPr>
+              <a:t>Multiple regulators create strength only if </a:t>
+            </a:r>
+            <a:r>
+              <a:rPr sz="1100" dirty="0" err="1">
+                <a:solidFill>
+                  <a:srgbClr val="2A2A2A"/>
+                </a:solidFill>
+                <a:latin typeface="Avenir Next" panose="020B0503020202020204" pitchFamily="34" charset="0"/>
+              </a:rPr>
+              <a:t>harmonised</a:t>
+            </a:r>
+            <a:r>
+              <a:rPr sz="1100" dirty="0">
+                <a:solidFill>
+                  <a:srgbClr val="2A2A2A"/>
+                </a:solidFill>
+                <a:latin typeface="Avenir Next" panose="020B0503020202020204" pitchFamily="34" charset="0"/>
+              </a:rPr>
+              <a:t>; uncoordinated overlap produces forum-shopping, regulatory arbitrage, and 'orphan' cases.</a:t>
+            </a:r>
+          </a:p>
+        </p:txBody>
+      </p:sp>
+      <p:sp>
+        <p:nvSpPr>
+          <p:cNvPr id="17" name="Rounded Rectangle 16"/>
           <p:cNvSpPr/>
           <p:nvPr/>
         </p:nvSpPr>
         <p:spPr>
           <a:xfrm>
-            <a:off x="7089561" y="1090843"/>
-            <a:ext cx="2057400" cy="2971559"/>
-          </a:xfrm>
-          <a:prstGeom prst="roundRect">
-            <a:avLst/>
-          </a:prstGeom>
-          <a:solidFill>
-            <a:srgbClr val="FFFDF8"/>
-          </a:solidFill>
-          <a:ln w="12700">
-            <a:solidFill>
-              <a:srgbClr val="D8D1C6"/>
-            </a:solidFill>
-          </a:ln>
-        </p:spPr>
-        <p:style>
-          <a:lnRef idx="1">
-            <a:schemeClr val="accent1"/>
-          </a:lnRef>
-          <a:fillRef idx="3">
-            <a:schemeClr val="accent1"/>
-          </a:fillRef>
-          <a:effectRef idx="2">
-            <a:schemeClr val="accent1"/>
-          </a:effectRef>
-          <a:fontRef idx="minor">
-            <a:schemeClr val="lt1"/>
-          </a:fontRef>
-        </p:style>
-        <p:txBody>
-          <a:bodyPr rtlCol="0" anchor="ctr"/>
-          <a:lstStyle/>
-          <a:p>
-            <a:pPr algn="ctr"/>
-            <a:endParaRPr sz="2000">
-              <a:latin typeface="Avenir Next" panose="020B0503020202020204" pitchFamily="34" charset="0"/>
-            </a:endParaRPr>
-          </a:p>
-        </p:txBody>
-      </p:sp>
-      <p:sp>
-        <p:nvSpPr>
-          <p:cNvPr id="19" name="Rectangle 18"/>
-          <p:cNvSpPr/>
-          <p:nvPr/>
-        </p:nvSpPr>
-        <p:spPr>
-          <a:xfrm>
-            <a:off x="7089561" y="1090843"/>
-            <a:ext cx="2057400" cy="89707"/>
-          </a:xfrm>
-          <a:prstGeom prst="rect">
-            <a:avLst/>
-          </a:prstGeom>
-          <a:solidFill>
-            <a:srgbClr val="C96A3D"/>
-          </a:solidFill>
-          <a:ln>
-            <a:noFill/>
-          </a:ln>
-        </p:spPr>
-        <p:style>
-          <a:lnRef idx="1">
-            <a:schemeClr val="accent1"/>
-          </a:lnRef>
-          <a:fillRef idx="3">
-            <a:schemeClr val="accent1"/>
-          </a:fillRef>
-          <a:effectRef idx="2">
-            <a:schemeClr val="accent1"/>
-          </a:effectRef>
-          <a:fontRef idx="minor">
-            <a:schemeClr val="lt1"/>
-          </a:fontRef>
-        </p:style>
-        <p:txBody>
-          <a:bodyPr rtlCol="0" anchor="ctr"/>
-          <a:lstStyle/>
-          <a:p>
-            <a:pPr algn="ctr"/>
-            <a:endParaRPr sz="2000">
-              <a:latin typeface="Avenir Next" panose="020B0503020202020204" pitchFamily="34" charset="0"/>
-            </a:endParaRPr>
-          </a:p>
-        </p:txBody>
-      </p:sp>
-      <p:sp>
-        <p:nvSpPr>
-          <p:cNvPr id="20" name="TextBox 19"/>
-          <p:cNvSpPr txBox="1"/>
-          <p:nvPr/>
-        </p:nvSpPr>
-        <p:spPr>
-          <a:xfrm>
-            <a:off x="7235865" y="1218860"/>
-            <a:ext cx="1764792" cy="584775"/>
-          </a:xfrm>
-          <a:prstGeom prst="rect">
-            <a:avLst/>
-          </a:prstGeom>
-          <a:noFill/>
-        </p:spPr>
-        <p:txBody>
-          <a:bodyPr wrap="square" anchor="t">
-            <a:spAutoFit/>
-          </a:bodyPr>
-          <a:lstStyle/>
-          <a:p>
-            <a:pPr algn="l">
-              <a:defRPr sz="1600" b="1">
-                <a:solidFill>
-                  <a:srgbClr val="173F35"/>
-                </a:solidFill>
-                <a:latin typeface="Avenir Next Demi Bold"/>
-              </a:defRPr>
-            </a:pPr>
-            <a:r>
-              <a:rPr>
-                <a:latin typeface="Avenir Next" panose="020B0503020202020204" pitchFamily="34" charset="0"/>
-              </a:rPr>
-              <a:t>4. Proactive surveillance</a:t>
-            </a:r>
-          </a:p>
-        </p:txBody>
-      </p:sp>
-      <p:sp>
-        <p:nvSpPr>
-          <p:cNvPr id="21" name="TextBox 20"/>
-          <p:cNvSpPr txBox="1"/>
-          <p:nvPr/>
-        </p:nvSpPr>
-        <p:spPr>
-          <a:xfrm>
-            <a:off x="7235865" y="1730924"/>
-            <a:ext cx="1764792" cy="1815882"/>
-          </a:xfrm>
-          <a:prstGeom prst="rect">
-            <a:avLst/>
-          </a:prstGeom>
-          <a:noFill/>
-        </p:spPr>
-        <p:txBody>
-          <a:bodyPr wrap="square" anchor="t">
-            <a:spAutoFit/>
-          </a:bodyPr>
-          <a:lstStyle/>
-          <a:p>
-            <a:pPr algn="l">
-              <a:defRPr sz="1200" b="0">
-                <a:solidFill>
-                  <a:srgbClr val="2A2A2A"/>
-                </a:solidFill>
-                <a:latin typeface="Avenir Next"/>
-              </a:defRPr>
-            </a:pPr>
-            <a:r>
-              <a:rPr sz="1400" dirty="0">
-                <a:latin typeface="Avenir Next" panose="020B0503020202020204" pitchFamily="34" charset="0"/>
-              </a:rPr>
-              <a:t>Run market sweeps in high-risk sectors and cross-check sustainability claims against pollution, compliance, and finance records.</a:t>
-            </a:r>
-          </a:p>
-        </p:txBody>
-      </p:sp>
-      <p:sp>
-        <p:nvSpPr>
-          <p:cNvPr id="22" name="Rounded Rectangle 21"/>
-          <p:cNvSpPr/>
-          <p:nvPr/>
-        </p:nvSpPr>
-        <p:spPr>
-          <a:xfrm>
-            <a:off x="9229257" y="1090843"/>
-            <a:ext cx="2057400" cy="2971559"/>
-          </a:xfrm>
-          <a:prstGeom prst="roundRect">
-            <a:avLst/>
-          </a:prstGeom>
-          <a:solidFill>
-            <a:srgbClr val="FFFDF8"/>
-          </a:solidFill>
-          <a:ln w="12700">
-            <a:solidFill>
-              <a:srgbClr val="D8D1C6"/>
-            </a:solidFill>
-          </a:ln>
-        </p:spPr>
-        <p:style>
-          <a:lnRef idx="1">
-            <a:schemeClr val="accent1"/>
-          </a:lnRef>
-          <a:fillRef idx="3">
-            <a:schemeClr val="accent1"/>
-          </a:fillRef>
-          <a:effectRef idx="2">
-            <a:schemeClr val="accent1"/>
-          </a:effectRef>
-          <a:fontRef idx="minor">
-            <a:schemeClr val="lt1"/>
-          </a:fontRef>
-        </p:style>
-        <p:txBody>
-          <a:bodyPr rtlCol="0" anchor="ctr"/>
-          <a:lstStyle/>
-          <a:p>
-            <a:pPr algn="ctr"/>
-            <a:endParaRPr sz="2000">
-              <a:latin typeface="Avenir Next" panose="020B0503020202020204" pitchFamily="34" charset="0"/>
-            </a:endParaRPr>
-          </a:p>
-        </p:txBody>
-      </p:sp>
-      <p:sp>
-        <p:nvSpPr>
-          <p:cNvPr id="23" name="Rectangle 22"/>
-          <p:cNvSpPr/>
-          <p:nvPr/>
-        </p:nvSpPr>
-        <p:spPr>
-          <a:xfrm>
-            <a:off x="9229257" y="1090843"/>
-            <a:ext cx="2057400" cy="89707"/>
-          </a:xfrm>
-          <a:prstGeom prst="rect">
-            <a:avLst/>
-          </a:prstGeom>
-          <a:solidFill>
-            <a:srgbClr val="A23E2A"/>
-          </a:solidFill>
-          <a:ln>
-            <a:noFill/>
-          </a:ln>
-        </p:spPr>
-        <p:style>
-          <a:lnRef idx="1">
-            <a:schemeClr val="accent1"/>
-          </a:lnRef>
-          <a:fillRef idx="3">
-            <a:schemeClr val="accent1"/>
-          </a:fillRef>
-          <a:effectRef idx="2">
-            <a:schemeClr val="accent1"/>
-          </a:effectRef>
-          <a:fontRef idx="minor">
-            <a:schemeClr val="lt1"/>
-          </a:fontRef>
-        </p:style>
-        <p:txBody>
-          <a:bodyPr rtlCol="0" anchor="ctr"/>
-          <a:lstStyle/>
-          <a:p>
-            <a:pPr algn="ctr"/>
-            <a:endParaRPr sz="2000">
-              <a:latin typeface="Avenir Next" panose="020B0503020202020204" pitchFamily="34" charset="0"/>
-            </a:endParaRPr>
-          </a:p>
-        </p:txBody>
-      </p:sp>
-      <p:sp>
-        <p:nvSpPr>
-          <p:cNvPr id="24" name="TextBox 23"/>
-          <p:cNvSpPr txBox="1"/>
-          <p:nvPr/>
-        </p:nvSpPr>
-        <p:spPr>
-          <a:xfrm>
-            <a:off x="9375561" y="1218860"/>
-            <a:ext cx="1764792" cy="584775"/>
-          </a:xfrm>
-          <a:prstGeom prst="rect">
-            <a:avLst/>
-          </a:prstGeom>
-          <a:noFill/>
-        </p:spPr>
-        <p:txBody>
-          <a:bodyPr wrap="square" anchor="t">
-            <a:spAutoFit/>
-          </a:bodyPr>
-          <a:lstStyle/>
-          <a:p>
-            <a:pPr algn="l">
-              <a:defRPr sz="1600" b="1">
-                <a:solidFill>
-                  <a:srgbClr val="173F35"/>
-                </a:solidFill>
-                <a:latin typeface="Avenir Next Demi Bold"/>
-              </a:defRPr>
-            </a:pPr>
-            <a:r>
-              <a:rPr>
-                <a:latin typeface="Avenir Next" panose="020B0503020202020204" pitchFamily="34" charset="0"/>
-              </a:rPr>
-              <a:t>5. Enforcement capacity</a:t>
-            </a:r>
-          </a:p>
-        </p:txBody>
-      </p:sp>
-      <p:sp>
-        <p:nvSpPr>
-          <p:cNvPr id="25" name="TextBox 24"/>
-          <p:cNvSpPr txBox="1"/>
-          <p:nvPr/>
-        </p:nvSpPr>
-        <p:spPr>
-          <a:xfrm>
-            <a:off x="9375561" y="1758356"/>
-            <a:ext cx="1764792" cy="1600438"/>
-          </a:xfrm>
-          <a:prstGeom prst="rect">
-            <a:avLst/>
-          </a:prstGeom>
-          <a:noFill/>
-        </p:spPr>
-        <p:txBody>
-          <a:bodyPr wrap="square" anchor="t">
-            <a:spAutoFit/>
-          </a:bodyPr>
-          <a:lstStyle/>
-          <a:p>
-            <a:pPr algn="l">
-              <a:defRPr sz="1200" b="0">
-                <a:solidFill>
-                  <a:srgbClr val="2A2A2A"/>
-                </a:solidFill>
-                <a:latin typeface="Avenir Next"/>
-              </a:defRPr>
-            </a:pPr>
-            <a:r>
-              <a:rPr sz="1400" dirty="0">
-                <a:latin typeface="Avenir Next" panose="020B0503020202020204" pitchFamily="34" charset="0"/>
-              </a:rPr>
-              <a:t>Build shared technical expertise on carbon accounting, offsets, lifecycle analysis, and ESG assurance.</a:t>
-            </a:r>
-          </a:p>
-        </p:txBody>
-      </p:sp>
-      <p:sp>
-        <p:nvSpPr>
-          <p:cNvPr id="26" name="Rounded Rectangle 25"/>
-          <p:cNvSpPr/>
-          <p:nvPr/>
-        </p:nvSpPr>
-        <p:spPr>
-          <a:xfrm>
-            <a:off x="1097280" y="4343019"/>
-            <a:ext cx="10012680" cy="1121343"/>
+            <a:off x="731520" y="5948020"/>
+            <a:ext cx="10735056" cy="680000"/>
           </a:xfrm>
           <a:prstGeom prst="roundRect">
             <a:avLst/>
@@ -19558,22 +19609,20 @@
           <a:lstStyle/>
           <a:p>
             <a:pPr algn="ctr"/>
-            <a:endParaRPr sz="2000">
-              <a:latin typeface="Avenir Next" panose="020B0503020202020204" pitchFamily="34" charset="0"/>
-            </a:endParaRPr>
-          </a:p>
-        </p:txBody>
-      </p:sp>
-      <p:sp>
-        <p:nvSpPr>
-          <p:cNvPr id="27" name="TextBox 26"/>
+            <a:endParaRPr/>
+          </a:p>
+        </p:txBody>
+      </p:sp>
+      <p:sp>
+        <p:nvSpPr>
+          <p:cNvPr id="18" name="TextBox 17"/>
           <p:cNvSpPr txBox="1"/>
           <p:nvPr/>
         </p:nvSpPr>
         <p:spPr>
           <a:xfrm>
-            <a:off x="1353312" y="4580764"/>
-            <a:ext cx="9509760" cy="707886"/>
+            <a:off x="861520" y="5988020"/>
+            <a:ext cx="10475056" cy="604781"/>
           </a:xfrm>
           <a:prstGeom prst="rect">
             <a:avLst/>
@@ -19581,38 +19630,47 @@
           <a:noFill/>
         </p:spPr>
         <p:txBody>
-          <a:bodyPr wrap="square" anchor="t">
+          <a:bodyPr wrap="square" lIns="0" tIns="0" rIns="0" bIns="0">
             <a:spAutoFit/>
           </a:bodyPr>
           <a:lstStyle/>
           <a:p>
-            <a:pPr algn="ctr">
-              <a:defRPr sz="1800" b="0">
+            <a:pPr algn="l">
+              <a:lnSpc>
+                <a:spcPct val="110000"/>
+              </a:lnSpc>
+            </a:pPr>
+            <a:r>
+              <a:rPr sz="1200" b="1" dirty="0">
                 <a:solidFill>
                   <a:srgbClr val="173F35"/>
                 </a:solidFill>
-                <a:latin typeface="Georgia"/>
-              </a:defRPr>
-            </a:pPr>
-            <a:r>
-              <a:rPr sz="2000" dirty="0">
-                <a:latin typeface="Avenir Next" panose="020B0503020202020204" pitchFamily="34" charset="0"/>
-              </a:rPr>
-              <a:t>Narrative takeaway: credible anti-greenwashing law starts before the claim is published, not after the complaint is filed.</a:t>
-            </a:r>
-          </a:p>
-        </p:txBody>
-      </p:sp>
-      <p:sp>
-        <p:nvSpPr>
-          <p:cNvPr id="28" name="TextBox 27"/>
+                <a:latin typeface="Avenir Next" panose="020B0503020202020204" pitchFamily="34" charset="0"/>
+              </a:rPr>
+              <a:t>All three hypotheses stand validated. </a:t>
+            </a:r>
+            <a:r>
+              <a:rPr sz="1200" dirty="0">
+                <a:solidFill>
+                  <a:srgbClr val="3A3A4A"/>
+                </a:solidFill>
+                <a:latin typeface="Avenir Next" panose="020B0503020202020204" pitchFamily="34" charset="0"/>
+              </a:rPr>
+              <a:t>Greenwashing in India is an upstream corporate governance failure (H₁), shielded by non-deterrent liability and narrow standing (H₂), and enabled by an uncoordinated, fragmented regulatory architecture (H₃) — confirming that piecemeal fixes fail and an integrated, sequenced corporate liability regime is necessary.</a:t>
+            </a:r>
+          </a:p>
+        </p:txBody>
+      </p:sp>
+      <p:sp>
+        <p:nvSpPr>
+          <p:cNvPr id="19" name="TextBox 18"/>
           <p:cNvSpPr txBox="1"/>
           <p:nvPr/>
         </p:nvSpPr>
         <p:spPr>
           <a:xfrm>
-            <a:off x="734355" y="6419873"/>
-            <a:ext cx="1596912" cy="246221"/>
+            <a:off x="730574" y="6692256"/>
+            <a:ext cx="1370568" cy="146194"/>
           </a:xfrm>
           <a:prstGeom prst="rect">
             <a:avLst/>
@@ -19620,37 +19678,24 @@
           <a:noFill/>
         </p:spPr>
         <p:txBody>
-          <a:bodyPr wrap="none">
+          <a:bodyPr wrap="none" lIns="0" tIns="0" rIns="0" bIns="0">
             <a:spAutoFit/>
           </a:bodyPr>
           <a:lstStyle/>
           <a:p>
-            <a:pPr>
-              <a:defRPr sz="850">
+            <a:r>
+              <a:rPr sz="950" dirty="0">
                 <a:solidFill>
                   <a:srgbClr val="6B6F6A"/>
                 </a:solidFill>
                 <a:latin typeface="Avenir Next"/>
-              </a:defRPr>
-            </a:pPr>
-            <a:r>
-              <a:rPr sz="1000" dirty="0"/>
-              <a:t>Source base: Chapter 6</a:t>
-            </a:r>
-            <a:r>
-              <a:rPr lang="en-US" sz="1000" dirty="0"/>
-              <a:t>.</a:t>
-            </a:r>
-            <a:endParaRPr sz="1000" dirty="0"/>
+              </a:rPr>
+              <a:t>Source base: Chapter 6 </a:t>
+            </a:r>
           </a:p>
         </p:txBody>
       </p:sp>
     </p:spTree>
-    <p:extLst>
-      <p:ext uri="{BB962C8B-B14F-4D97-AF65-F5344CB8AC3E}">
-        <p14:creationId xmlns:p14="http://schemas.microsoft.com/office/powerpoint/2010/main" val="918971880"/>
-      </p:ext>
-    </p:extLst>
   </p:cSld>
   <p:clrMapOvr>
     <a:masterClrMapping/>
@@ -19728,6 +19773,1188 @@
         <p:spPr>
           <a:xfrm>
             <a:off x="548639" y="384048"/>
+            <a:ext cx="8968847" cy="584775"/>
+          </a:xfrm>
+          <a:prstGeom prst="rect">
+            <a:avLst/>
+          </a:prstGeom>
+          <a:noFill/>
+        </p:spPr>
+        <p:txBody>
+          <a:bodyPr wrap="square">
+            <a:spAutoFit/>
+          </a:bodyPr>
+          <a:lstStyle/>
+          <a:p>
+            <a:pPr>
+              <a:defRPr sz="2200" b="1">
+                <a:solidFill>
+                  <a:srgbClr val="173F35"/>
+                </a:solidFill>
+                <a:latin typeface="Avenir Next Demi Bold"/>
+              </a:defRPr>
+            </a:pPr>
+            <a:r>
+              <a:rPr lang="en-US" sz="3200" dirty="0"/>
+              <a:t>General Suggestions For Regulatory Reform</a:t>
+            </a:r>
+            <a:endParaRPr sz="3200" dirty="0"/>
+          </a:p>
+        </p:txBody>
+      </p:sp>
+      <p:sp>
+        <p:nvSpPr>
+          <p:cNvPr id="5" name="TextBox 4"/>
+          <p:cNvSpPr txBox="1"/>
+          <p:nvPr/>
+        </p:nvSpPr>
+        <p:spPr>
+          <a:xfrm>
+            <a:off x="734355" y="5702107"/>
+            <a:ext cx="11000000" cy="692497"/>
+          </a:xfrm>
+          <a:prstGeom prst="rect">
+            <a:avLst/>
+          </a:prstGeom>
+          <a:noFill/>
+        </p:spPr>
+        <p:txBody>
+          <a:bodyPr wrap="square">
+            <a:spAutoFit/>
+          </a:bodyPr>
+          <a:lstStyle/>
+          <a:p>
+            <a:pPr>
+              <a:defRPr sz="1200">
+                <a:solidFill>
+                  <a:srgbClr val="6B6F6A"/>
+                </a:solidFill>
+                <a:latin typeface="Avenir Next"/>
+              </a:defRPr>
+            </a:pPr>
+            <a:r>
+              <a:rPr sz="1400" b="0" dirty="0">
+                <a:solidFill>
+                  <a:srgbClr val="6B6F6A"/>
+                </a:solidFill>
+                <a:latin typeface="Avenir Next"/>
+              </a:rPr>
+              <a:t>Research Question 7 (part 1): </a:t>
+            </a:r>
+            <a:r>
+              <a:rPr lang="en-IN" sz="1400" dirty="0">
+                <a:ea typeface="+mn-lt"/>
+                <a:cs typeface="+mn-lt"/>
+              </a:rPr>
+              <a:t>What legal and policy recommendations can create an integrated liability framework that holds corporations accountable for misleading environmental claims?</a:t>
+            </a:r>
+            <a:endParaRPr lang="en-US" sz="1400" dirty="0">
+              <a:ea typeface="+mn-lt"/>
+              <a:cs typeface="+mn-lt"/>
+            </a:endParaRPr>
+          </a:p>
+          <a:p>
+            <a:pPr>
+              <a:defRPr sz="1200">
+                <a:solidFill>
+                  <a:srgbClr val="6B6F6A"/>
+                </a:solidFill>
+                <a:latin typeface="Avenir Next"/>
+              </a:defRPr>
+            </a:pPr>
+            <a:endParaRPr sz="1100" b="0" dirty="0">
+              <a:solidFill>
+                <a:srgbClr val="6B6F6A"/>
+              </a:solidFill>
+              <a:latin typeface="Avenir Next"/>
+            </a:endParaRPr>
+          </a:p>
+        </p:txBody>
+      </p:sp>
+      <p:sp>
+        <p:nvSpPr>
+          <p:cNvPr id="6" name="Rounded Rectangle 5"/>
+          <p:cNvSpPr/>
+          <p:nvPr/>
+        </p:nvSpPr>
+        <p:spPr>
+          <a:xfrm>
+            <a:off x="670473" y="1090843"/>
+            <a:ext cx="2057400" cy="2971559"/>
+          </a:xfrm>
+          <a:prstGeom prst="roundRect">
+            <a:avLst/>
+          </a:prstGeom>
+          <a:solidFill>
+            <a:srgbClr val="FFFDF8"/>
+          </a:solidFill>
+          <a:ln w="12700">
+            <a:solidFill>
+              <a:srgbClr val="D8D1C6"/>
+            </a:solidFill>
+          </a:ln>
+        </p:spPr>
+        <p:style>
+          <a:lnRef idx="1">
+            <a:schemeClr val="accent1"/>
+          </a:lnRef>
+          <a:fillRef idx="3">
+            <a:schemeClr val="accent1"/>
+          </a:fillRef>
+          <a:effectRef idx="2">
+            <a:schemeClr val="accent1"/>
+          </a:effectRef>
+          <a:fontRef idx="minor">
+            <a:schemeClr val="lt1"/>
+          </a:fontRef>
+        </p:style>
+        <p:txBody>
+          <a:bodyPr rtlCol="0" anchor="ctr"/>
+          <a:lstStyle/>
+          <a:p>
+            <a:pPr algn="ctr"/>
+            <a:endParaRPr sz="2000">
+              <a:latin typeface="Avenir Next" panose="020B0503020202020204" pitchFamily="34" charset="0"/>
+            </a:endParaRPr>
+          </a:p>
+        </p:txBody>
+      </p:sp>
+      <p:sp>
+        <p:nvSpPr>
+          <p:cNvPr id="7" name="Rectangle 6"/>
+          <p:cNvSpPr/>
+          <p:nvPr/>
+        </p:nvSpPr>
+        <p:spPr>
+          <a:xfrm>
+            <a:off x="670473" y="1090843"/>
+            <a:ext cx="2057400" cy="89707"/>
+          </a:xfrm>
+          <a:prstGeom prst="rect">
+            <a:avLst/>
+          </a:prstGeom>
+          <a:solidFill>
+            <a:srgbClr val="C96A3D"/>
+          </a:solidFill>
+          <a:ln>
+            <a:noFill/>
+          </a:ln>
+        </p:spPr>
+        <p:style>
+          <a:lnRef idx="1">
+            <a:schemeClr val="accent1"/>
+          </a:lnRef>
+          <a:fillRef idx="3">
+            <a:schemeClr val="accent1"/>
+          </a:fillRef>
+          <a:effectRef idx="2">
+            <a:schemeClr val="accent1"/>
+          </a:effectRef>
+          <a:fontRef idx="minor">
+            <a:schemeClr val="lt1"/>
+          </a:fontRef>
+        </p:style>
+        <p:txBody>
+          <a:bodyPr rtlCol="0" anchor="ctr"/>
+          <a:lstStyle/>
+          <a:p>
+            <a:pPr algn="ctr"/>
+            <a:endParaRPr sz="2000">
+              <a:latin typeface="Avenir Next" panose="020B0503020202020204" pitchFamily="34" charset="0"/>
+            </a:endParaRPr>
+          </a:p>
+        </p:txBody>
+      </p:sp>
+      <p:sp>
+        <p:nvSpPr>
+          <p:cNvPr id="8" name="TextBox 7"/>
+          <p:cNvSpPr txBox="1"/>
+          <p:nvPr/>
+        </p:nvSpPr>
+        <p:spPr>
+          <a:xfrm>
+            <a:off x="816777" y="1218860"/>
+            <a:ext cx="1764792" cy="584775"/>
+          </a:xfrm>
+          <a:prstGeom prst="rect">
+            <a:avLst/>
+          </a:prstGeom>
+          <a:noFill/>
+        </p:spPr>
+        <p:txBody>
+          <a:bodyPr wrap="square" anchor="t">
+            <a:spAutoFit/>
+          </a:bodyPr>
+          <a:lstStyle/>
+          <a:p>
+            <a:pPr algn="l">
+              <a:defRPr sz="1600" b="1">
+                <a:solidFill>
+                  <a:srgbClr val="173F35"/>
+                </a:solidFill>
+                <a:latin typeface="Avenir Next Demi Bold"/>
+              </a:defRPr>
+            </a:pPr>
+            <a:r>
+              <a:rPr>
+                <a:latin typeface="Avenir Next" panose="020B0503020202020204" pitchFamily="34" charset="0"/>
+              </a:rPr>
+              <a:t>1. Institutional integration</a:t>
+            </a:r>
+          </a:p>
+        </p:txBody>
+      </p:sp>
+      <p:sp>
+        <p:nvSpPr>
+          <p:cNvPr id="9" name="TextBox 8"/>
+          <p:cNvSpPr txBox="1"/>
+          <p:nvPr/>
+        </p:nvSpPr>
+        <p:spPr>
+          <a:xfrm>
+            <a:off x="816777" y="1730924"/>
+            <a:ext cx="1764792" cy="2031325"/>
+          </a:xfrm>
+          <a:prstGeom prst="rect">
+            <a:avLst/>
+          </a:prstGeom>
+          <a:noFill/>
+        </p:spPr>
+        <p:txBody>
+          <a:bodyPr wrap="square" anchor="t">
+            <a:spAutoFit/>
+          </a:bodyPr>
+          <a:lstStyle/>
+          <a:p>
+            <a:pPr algn="l">
+              <a:defRPr sz="1200" b="0">
+                <a:solidFill>
+                  <a:srgbClr val="2A2A2A"/>
+                </a:solidFill>
+                <a:latin typeface="Avenir Next"/>
+              </a:defRPr>
+            </a:pPr>
+            <a:r>
+              <a:rPr sz="1400" dirty="0">
+                <a:latin typeface="Avenir Next" panose="020B0503020202020204" pitchFamily="34" charset="0"/>
+              </a:rPr>
+              <a:t>Create a permanent inter-regulatory greenwashing mechanism linking MCA, SEBI, CCPA, </a:t>
+            </a:r>
+            <a:r>
+              <a:rPr sz="1400" dirty="0" err="1">
+                <a:latin typeface="Avenir Next" panose="020B0503020202020204" pitchFamily="34" charset="0"/>
+              </a:rPr>
+              <a:t>MoEFCC</a:t>
+            </a:r>
+            <a:r>
+              <a:rPr sz="1400" dirty="0">
+                <a:latin typeface="Avenir Next" panose="020B0503020202020204" pitchFamily="34" charset="0"/>
+              </a:rPr>
+              <a:t>, CPCB, BIS, FSSAI, and sectoral bodies.</a:t>
+            </a:r>
+          </a:p>
+        </p:txBody>
+      </p:sp>
+      <p:sp>
+        <p:nvSpPr>
+          <p:cNvPr id="10" name="Rounded Rectangle 9"/>
+          <p:cNvSpPr/>
+          <p:nvPr/>
+        </p:nvSpPr>
+        <p:spPr>
+          <a:xfrm>
+            <a:off x="2810169" y="1090843"/>
+            <a:ext cx="2057400" cy="2971559"/>
+          </a:xfrm>
+          <a:prstGeom prst="roundRect">
+            <a:avLst/>
+          </a:prstGeom>
+          <a:solidFill>
+            <a:srgbClr val="FFFDF8"/>
+          </a:solidFill>
+          <a:ln w="12700">
+            <a:solidFill>
+              <a:srgbClr val="D8D1C6"/>
+            </a:solidFill>
+          </a:ln>
+        </p:spPr>
+        <p:style>
+          <a:lnRef idx="1">
+            <a:schemeClr val="accent1"/>
+          </a:lnRef>
+          <a:fillRef idx="3">
+            <a:schemeClr val="accent1"/>
+          </a:fillRef>
+          <a:effectRef idx="2">
+            <a:schemeClr val="accent1"/>
+          </a:effectRef>
+          <a:fontRef idx="minor">
+            <a:schemeClr val="lt1"/>
+          </a:fontRef>
+        </p:style>
+        <p:txBody>
+          <a:bodyPr rtlCol="0" anchor="ctr"/>
+          <a:lstStyle/>
+          <a:p>
+            <a:pPr algn="ctr"/>
+            <a:endParaRPr sz="2000">
+              <a:latin typeface="Avenir Next" panose="020B0503020202020204" pitchFamily="34" charset="0"/>
+            </a:endParaRPr>
+          </a:p>
+        </p:txBody>
+      </p:sp>
+      <p:sp>
+        <p:nvSpPr>
+          <p:cNvPr id="11" name="Rectangle 10"/>
+          <p:cNvSpPr/>
+          <p:nvPr/>
+        </p:nvSpPr>
+        <p:spPr>
+          <a:xfrm>
+            <a:off x="2810169" y="1090843"/>
+            <a:ext cx="2057400" cy="89707"/>
+          </a:xfrm>
+          <a:prstGeom prst="rect">
+            <a:avLst/>
+          </a:prstGeom>
+          <a:solidFill>
+            <a:srgbClr val="C8A24D"/>
+          </a:solidFill>
+          <a:ln>
+            <a:noFill/>
+          </a:ln>
+        </p:spPr>
+        <p:style>
+          <a:lnRef idx="1">
+            <a:schemeClr val="accent1"/>
+          </a:lnRef>
+          <a:fillRef idx="3">
+            <a:schemeClr val="accent1"/>
+          </a:fillRef>
+          <a:effectRef idx="2">
+            <a:schemeClr val="accent1"/>
+          </a:effectRef>
+          <a:fontRef idx="minor">
+            <a:schemeClr val="lt1"/>
+          </a:fontRef>
+        </p:style>
+        <p:txBody>
+          <a:bodyPr rtlCol="0" anchor="ctr"/>
+          <a:lstStyle/>
+          <a:p>
+            <a:pPr algn="ctr"/>
+            <a:endParaRPr sz="2000">
+              <a:latin typeface="Avenir Next" panose="020B0503020202020204" pitchFamily="34" charset="0"/>
+            </a:endParaRPr>
+          </a:p>
+        </p:txBody>
+      </p:sp>
+      <p:sp>
+        <p:nvSpPr>
+          <p:cNvPr id="12" name="TextBox 11"/>
+          <p:cNvSpPr txBox="1"/>
+          <p:nvPr/>
+        </p:nvSpPr>
+        <p:spPr>
+          <a:xfrm>
+            <a:off x="2956473" y="1218860"/>
+            <a:ext cx="1764792" cy="830997"/>
+          </a:xfrm>
+          <a:prstGeom prst="rect">
+            <a:avLst/>
+          </a:prstGeom>
+          <a:noFill/>
+        </p:spPr>
+        <p:txBody>
+          <a:bodyPr wrap="square" anchor="t">
+            <a:spAutoFit/>
+          </a:bodyPr>
+          <a:lstStyle/>
+          <a:p>
+            <a:pPr algn="l">
+              <a:defRPr sz="1600" b="1">
+                <a:solidFill>
+                  <a:srgbClr val="173F35"/>
+                </a:solidFill>
+                <a:latin typeface="Avenir Next Demi Bold"/>
+              </a:defRPr>
+            </a:pPr>
+            <a:r>
+              <a:rPr dirty="0">
+                <a:latin typeface="Avenir Next" panose="020B0503020202020204" pitchFamily="34" charset="0"/>
+              </a:rPr>
+              <a:t>2. Lead regulator model</a:t>
+            </a:r>
+          </a:p>
+        </p:txBody>
+      </p:sp>
+      <p:sp>
+        <p:nvSpPr>
+          <p:cNvPr id="13" name="TextBox 12"/>
+          <p:cNvSpPr txBox="1"/>
+          <p:nvPr/>
+        </p:nvSpPr>
+        <p:spPr>
+          <a:xfrm>
+            <a:off x="2956473" y="1730924"/>
+            <a:ext cx="1764792" cy="1815882"/>
+          </a:xfrm>
+          <a:prstGeom prst="rect">
+            <a:avLst/>
+          </a:prstGeom>
+          <a:noFill/>
+        </p:spPr>
+        <p:txBody>
+          <a:bodyPr wrap="square" anchor="t">
+            <a:spAutoFit/>
+          </a:bodyPr>
+          <a:lstStyle/>
+          <a:p>
+            <a:pPr algn="l">
+              <a:defRPr sz="1200" b="0">
+                <a:solidFill>
+                  <a:srgbClr val="2A2A2A"/>
+                </a:solidFill>
+                <a:latin typeface="Avenir Next"/>
+              </a:defRPr>
+            </a:pPr>
+            <a:r>
+              <a:rPr sz="1400" dirty="0">
+                <a:latin typeface="Avenir Next" panose="020B0503020202020204" pitchFamily="34" charset="0"/>
+              </a:rPr>
+              <a:t>Use mandatory cross-referrals, shared evidence protocols, and a rule for who coordinates a claim that travels across the market.</a:t>
+            </a:r>
+          </a:p>
+        </p:txBody>
+      </p:sp>
+      <p:sp>
+        <p:nvSpPr>
+          <p:cNvPr id="14" name="Rounded Rectangle 13"/>
+          <p:cNvSpPr/>
+          <p:nvPr/>
+        </p:nvSpPr>
+        <p:spPr>
+          <a:xfrm>
+            <a:off x="4949865" y="1090843"/>
+            <a:ext cx="2057400" cy="2971559"/>
+          </a:xfrm>
+          <a:prstGeom prst="roundRect">
+            <a:avLst/>
+          </a:prstGeom>
+          <a:solidFill>
+            <a:srgbClr val="FFFDF8"/>
+          </a:solidFill>
+          <a:ln w="12700">
+            <a:solidFill>
+              <a:srgbClr val="D8D1C6"/>
+            </a:solidFill>
+          </a:ln>
+        </p:spPr>
+        <p:style>
+          <a:lnRef idx="1">
+            <a:schemeClr val="accent1"/>
+          </a:lnRef>
+          <a:fillRef idx="3">
+            <a:schemeClr val="accent1"/>
+          </a:fillRef>
+          <a:effectRef idx="2">
+            <a:schemeClr val="accent1"/>
+          </a:effectRef>
+          <a:fontRef idx="minor">
+            <a:schemeClr val="lt1"/>
+          </a:fontRef>
+        </p:style>
+        <p:txBody>
+          <a:bodyPr rtlCol="0" anchor="ctr"/>
+          <a:lstStyle/>
+          <a:p>
+            <a:pPr algn="ctr"/>
+            <a:endParaRPr sz="2000">
+              <a:latin typeface="Avenir Next" panose="020B0503020202020204" pitchFamily="34" charset="0"/>
+            </a:endParaRPr>
+          </a:p>
+        </p:txBody>
+      </p:sp>
+      <p:sp>
+        <p:nvSpPr>
+          <p:cNvPr id="15" name="Rectangle 14"/>
+          <p:cNvSpPr/>
+          <p:nvPr/>
+        </p:nvSpPr>
+        <p:spPr>
+          <a:xfrm>
+            <a:off x="4949865" y="1090843"/>
+            <a:ext cx="2057400" cy="89707"/>
+          </a:xfrm>
+          <a:prstGeom prst="rect">
+            <a:avLst/>
+          </a:prstGeom>
+          <a:solidFill>
+            <a:srgbClr val="6A8C69"/>
+          </a:solidFill>
+          <a:ln>
+            <a:noFill/>
+          </a:ln>
+        </p:spPr>
+        <p:style>
+          <a:lnRef idx="1">
+            <a:schemeClr val="accent1"/>
+          </a:lnRef>
+          <a:fillRef idx="3">
+            <a:schemeClr val="accent1"/>
+          </a:fillRef>
+          <a:effectRef idx="2">
+            <a:schemeClr val="accent1"/>
+          </a:effectRef>
+          <a:fontRef idx="minor">
+            <a:schemeClr val="lt1"/>
+          </a:fontRef>
+        </p:style>
+        <p:txBody>
+          <a:bodyPr rtlCol="0" anchor="ctr"/>
+          <a:lstStyle/>
+          <a:p>
+            <a:pPr algn="ctr"/>
+            <a:endParaRPr sz="2000">
+              <a:latin typeface="Avenir Next" panose="020B0503020202020204" pitchFamily="34" charset="0"/>
+            </a:endParaRPr>
+          </a:p>
+        </p:txBody>
+      </p:sp>
+      <p:sp>
+        <p:nvSpPr>
+          <p:cNvPr id="16" name="TextBox 15"/>
+          <p:cNvSpPr txBox="1"/>
+          <p:nvPr/>
+        </p:nvSpPr>
+        <p:spPr>
+          <a:xfrm>
+            <a:off x="5096169" y="1218860"/>
+            <a:ext cx="1764792" cy="584775"/>
+          </a:xfrm>
+          <a:prstGeom prst="rect">
+            <a:avLst/>
+          </a:prstGeom>
+          <a:noFill/>
+        </p:spPr>
+        <p:txBody>
+          <a:bodyPr wrap="square" anchor="t">
+            <a:spAutoFit/>
+          </a:bodyPr>
+          <a:lstStyle/>
+          <a:p>
+            <a:pPr algn="l">
+              <a:defRPr sz="1600" b="1">
+                <a:solidFill>
+                  <a:srgbClr val="173F35"/>
+                </a:solidFill>
+                <a:latin typeface="Avenir Next Demi Bold"/>
+              </a:defRPr>
+            </a:pPr>
+            <a:r>
+              <a:rPr>
+                <a:latin typeface="Avenir Next" panose="020B0503020202020204" pitchFamily="34" charset="0"/>
+              </a:rPr>
+              <a:t>3. Standardised substantiation</a:t>
+            </a:r>
+          </a:p>
+        </p:txBody>
+      </p:sp>
+      <p:sp>
+        <p:nvSpPr>
+          <p:cNvPr id="17" name="TextBox 16"/>
+          <p:cNvSpPr txBox="1"/>
+          <p:nvPr/>
+        </p:nvSpPr>
+        <p:spPr>
+          <a:xfrm>
+            <a:off x="5096169" y="1758356"/>
+            <a:ext cx="1764792" cy="2031325"/>
+          </a:xfrm>
+          <a:prstGeom prst="rect">
+            <a:avLst/>
+          </a:prstGeom>
+          <a:noFill/>
+        </p:spPr>
+        <p:txBody>
+          <a:bodyPr wrap="square" anchor="t">
+            <a:spAutoFit/>
+          </a:bodyPr>
+          <a:lstStyle/>
+          <a:p>
+            <a:pPr algn="l">
+              <a:defRPr sz="1200" b="0">
+                <a:solidFill>
+                  <a:srgbClr val="2A2A2A"/>
+                </a:solidFill>
+                <a:latin typeface="Avenir Next"/>
+              </a:defRPr>
+            </a:pPr>
+            <a:r>
+              <a:rPr sz="1400" dirty="0">
+                <a:latin typeface="Avenir Next" panose="020B0503020202020204" pitchFamily="34" charset="0"/>
+              </a:rPr>
+              <a:t>Move toward lifecycle-based verification, product-category rules, accredited verifiers, and common evidentiary standards.</a:t>
+            </a:r>
+          </a:p>
+        </p:txBody>
+      </p:sp>
+      <p:sp>
+        <p:nvSpPr>
+          <p:cNvPr id="18" name="Rounded Rectangle 17"/>
+          <p:cNvSpPr/>
+          <p:nvPr/>
+        </p:nvSpPr>
+        <p:spPr>
+          <a:xfrm>
+            <a:off x="7089561" y="1090843"/>
+            <a:ext cx="2057400" cy="2971559"/>
+          </a:xfrm>
+          <a:prstGeom prst="roundRect">
+            <a:avLst/>
+          </a:prstGeom>
+          <a:solidFill>
+            <a:srgbClr val="FFFDF8"/>
+          </a:solidFill>
+          <a:ln w="12700">
+            <a:solidFill>
+              <a:srgbClr val="D8D1C6"/>
+            </a:solidFill>
+          </a:ln>
+        </p:spPr>
+        <p:style>
+          <a:lnRef idx="1">
+            <a:schemeClr val="accent1"/>
+          </a:lnRef>
+          <a:fillRef idx="3">
+            <a:schemeClr val="accent1"/>
+          </a:fillRef>
+          <a:effectRef idx="2">
+            <a:schemeClr val="accent1"/>
+          </a:effectRef>
+          <a:fontRef idx="minor">
+            <a:schemeClr val="lt1"/>
+          </a:fontRef>
+        </p:style>
+        <p:txBody>
+          <a:bodyPr rtlCol="0" anchor="ctr"/>
+          <a:lstStyle/>
+          <a:p>
+            <a:pPr algn="ctr"/>
+            <a:endParaRPr sz="2000">
+              <a:latin typeface="Avenir Next" panose="020B0503020202020204" pitchFamily="34" charset="0"/>
+            </a:endParaRPr>
+          </a:p>
+        </p:txBody>
+      </p:sp>
+      <p:sp>
+        <p:nvSpPr>
+          <p:cNvPr id="19" name="Rectangle 18"/>
+          <p:cNvSpPr/>
+          <p:nvPr/>
+        </p:nvSpPr>
+        <p:spPr>
+          <a:xfrm>
+            <a:off x="7089561" y="1090843"/>
+            <a:ext cx="2057400" cy="89707"/>
+          </a:xfrm>
+          <a:prstGeom prst="rect">
+            <a:avLst/>
+          </a:prstGeom>
+          <a:solidFill>
+            <a:srgbClr val="C96A3D"/>
+          </a:solidFill>
+          <a:ln>
+            <a:noFill/>
+          </a:ln>
+        </p:spPr>
+        <p:style>
+          <a:lnRef idx="1">
+            <a:schemeClr val="accent1"/>
+          </a:lnRef>
+          <a:fillRef idx="3">
+            <a:schemeClr val="accent1"/>
+          </a:fillRef>
+          <a:effectRef idx="2">
+            <a:schemeClr val="accent1"/>
+          </a:effectRef>
+          <a:fontRef idx="minor">
+            <a:schemeClr val="lt1"/>
+          </a:fontRef>
+        </p:style>
+        <p:txBody>
+          <a:bodyPr rtlCol="0" anchor="ctr"/>
+          <a:lstStyle/>
+          <a:p>
+            <a:pPr algn="ctr"/>
+            <a:endParaRPr sz="2000">
+              <a:latin typeface="Avenir Next" panose="020B0503020202020204" pitchFamily="34" charset="0"/>
+            </a:endParaRPr>
+          </a:p>
+        </p:txBody>
+      </p:sp>
+      <p:sp>
+        <p:nvSpPr>
+          <p:cNvPr id="20" name="TextBox 19"/>
+          <p:cNvSpPr txBox="1"/>
+          <p:nvPr/>
+        </p:nvSpPr>
+        <p:spPr>
+          <a:xfrm>
+            <a:off x="7235865" y="1218860"/>
+            <a:ext cx="1764792" cy="584775"/>
+          </a:xfrm>
+          <a:prstGeom prst="rect">
+            <a:avLst/>
+          </a:prstGeom>
+          <a:noFill/>
+        </p:spPr>
+        <p:txBody>
+          <a:bodyPr wrap="square" anchor="t">
+            <a:spAutoFit/>
+          </a:bodyPr>
+          <a:lstStyle/>
+          <a:p>
+            <a:pPr algn="l">
+              <a:defRPr sz="1600" b="1">
+                <a:solidFill>
+                  <a:srgbClr val="173F35"/>
+                </a:solidFill>
+                <a:latin typeface="Avenir Next Demi Bold"/>
+              </a:defRPr>
+            </a:pPr>
+            <a:r>
+              <a:rPr>
+                <a:latin typeface="Avenir Next" panose="020B0503020202020204" pitchFamily="34" charset="0"/>
+              </a:rPr>
+              <a:t>4. Proactive surveillance</a:t>
+            </a:r>
+          </a:p>
+        </p:txBody>
+      </p:sp>
+      <p:sp>
+        <p:nvSpPr>
+          <p:cNvPr id="21" name="TextBox 20"/>
+          <p:cNvSpPr txBox="1"/>
+          <p:nvPr/>
+        </p:nvSpPr>
+        <p:spPr>
+          <a:xfrm>
+            <a:off x="7235865" y="1730924"/>
+            <a:ext cx="1764792" cy="1815882"/>
+          </a:xfrm>
+          <a:prstGeom prst="rect">
+            <a:avLst/>
+          </a:prstGeom>
+          <a:noFill/>
+        </p:spPr>
+        <p:txBody>
+          <a:bodyPr wrap="square" anchor="t">
+            <a:spAutoFit/>
+          </a:bodyPr>
+          <a:lstStyle/>
+          <a:p>
+            <a:pPr algn="l">
+              <a:defRPr sz="1200" b="0">
+                <a:solidFill>
+                  <a:srgbClr val="2A2A2A"/>
+                </a:solidFill>
+                <a:latin typeface="Avenir Next"/>
+              </a:defRPr>
+            </a:pPr>
+            <a:r>
+              <a:rPr sz="1400" dirty="0">
+                <a:latin typeface="Avenir Next" panose="020B0503020202020204" pitchFamily="34" charset="0"/>
+              </a:rPr>
+              <a:t>Run market sweeps in high-risk sectors and cross-check sustainability claims against pollution, compliance, and finance records.</a:t>
+            </a:r>
+          </a:p>
+        </p:txBody>
+      </p:sp>
+      <p:sp>
+        <p:nvSpPr>
+          <p:cNvPr id="22" name="Rounded Rectangle 21"/>
+          <p:cNvSpPr/>
+          <p:nvPr/>
+        </p:nvSpPr>
+        <p:spPr>
+          <a:xfrm>
+            <a:off x="9229257" y="1090843"/>
+            <a:ext cx="2057400" cy="2971559"/>
+          </a:xfrm>
+          <a:prstGeom prst="roundRect">
+            <a:avLst/>
+          </a:prstGeom>
+          <a:solidFill>
+            <a:srgbClr val="FFFDF8"/>
+          </a:solidFill>
+          <a:ln w="12700">
+            <a:solidFill>
+              <a:srgbClr val="D8D1C6"/>
+            </a:solidFill>
+          </a:ln>
+        </p:spPr>
+        <p:style>
+          <a:lnRef idx="1">
+            <a:schemeClr val="accent1"/>
+          </a:lnRef>
+          <a:fillRef idx="3">
+            <a:schemeClr val="accent1"/>
+          </a:fillRef>
+          <a:effectRef idx="2">
+            <a:schemeClr val="accent1"/>
+          </a:effectRef>
+          <a:fontRef idx="minor">
+            <a:schemeClr val="lt1"/>
+          </a:fontRef>
+        </p:style>
+        <p:txBody>
+          <a:bodyPr rtlCol="0" anchor="ctr"/>
+          <a:lstStyle/>
+          <a:p>
+            <a:pPr algn="ctr"/>
+            <a:endParaRPr sz="2000">
+              <a:latin typeface="Avenir Next" panose="020B0503020202020204" pitchFamily="34" charset="0"/>
+            </a:endParaRPr>
+          </a:p>
+        </p:txBody>
+      </p:sp>
+      <p:sp>
+        <p:nvSpPr>
+          <p:cNvPr id="23" name="Rectangle 22"/>
+          <p:cNvSpPr/>
+          <p:nvPr/>
+        </p:nvSpPr>
+        <p:spPr>
+          <a:xfrm>
+            <a:off x="9229257" y="1090843"/>
+            <a:ext cx="2057400" cy="89707"/>
+          </a:xfrm>
+          <a:prstGeom prst="rect">
+            <a:avLst/>
+          </a:prstGeom>
+          <a:solidFill>
+            <a:srgbClr val="A23E2A"/>
+          </a:solidFill>
+          <a:ln>
+            <a:noFill/>
+          </a:ln>
+        </p:spPr>
+        <p:style>
+          <a:lnRef idx="1">
+            <a:schemeClr val="accent1"/>
+          </a:lnRef>
+          <a:fillRef idx="3">
+            <a:schemeClr val="accent1"/>
+          </a:fillRef>
+          <a:effectRef idx="2">
+            <a:schemeClr val="accent1"/>
+          </a:effectRef>
+          <a:fontRef idx="minor">
+            <a:schemeClr val="lt1"/>
+          </a:fontRef>
+        </p:style>
+        <p:txBody>
+          <a:bodyPr rtlCol="0" anchor="ctr"/>
+          <a:lstStyle/>
+          <a:p>
+            <a:pPr algn="ctr"/>
+            <a:endParaRPr sz="2000">
+              <a:latin typeface="Avenir Next" panose="020B0503020202020204" pitchFamily="34" charset="0"/>
+            </a:endParaRPr>
+          </a:p>
+        </p:txBody>
+      </p:sp>
+      <p:sp>
+        <p:nvSpPr>
+          <p:cNvPr id="24" name="TextBox 23"/>
+          <p:cNvSpPr txBox="1"/>
+          <p:nvPr/>
+        </p:nvSpPr>
+        <p:spPr>
+          <a:xfrm>
+            <a:off x="9375561" y="1218860"/>
+            <a:ext cx="1764792" cy="584775"/>
+          </a:xfrm>
+          <a:prstGeom prst="rect">
+            <a:avLst/>
+          </a:prstGeom>
+          <a:noFill/>
+        </p:spPr>
+        <p:txBody>
+          <a:bodyPr wrap="square" anchor="t">
+            <a:spAutoFit/>
+          </a:bodyPr>
+          <a:lstStyle/>
+          <a:p>
+            <a:pPr algn="l">
+              <a:defRPr sz="1600" b="1">
+                <a:solidFill>
+                  <a:srgbClr val="173F35"/>
+                </a:solidFill>
+                <a:latin typeface="Avenir Next Demi Bold"/>
+              </a:defRPr>
+            </a:pPr>
+            <a:r>
+              <a:rPr>
+                <a:latin typeface="Avenir Next" panose="020B0503020202020204" pitchFamily="34" charset="0"/>
+              </a:rPr>
+              <a:t>5. Enforcement capacity</a:t>
+            </a:r>
+          </a:p>
+        </p:txBody>
+      </p:sp>
+      <p:sp>
+        <p:nvSpPr>
+          <p:cNvPr id="25" name="TextBox 24"/>
+          <p:cNvSpPr txBox="1"/>
+          <p:nvPr/>
+        </p:nvSpPr>
+        <p:spPr>
+          <a:xfrm>
+            <a:off x="9375561" y="1758356"/>
+            <a:ext cx="1764792" cy="1600438"/>
+          </a:xfrm>
+          <a:prstGeom prst="rect">
+            <a:avLst/>
+          </a:prstGeom>
+          <a:noFill/>
+        </p:spPr>
+        <p:txBody>
+          <a:bodyPr wrap="square" anchor="t">
+            <a:spAutoFit/>
+          </a:bodyPr>
+          <a:lstStyle/>
+          <a:p>
+            <a:pPr algn="l">
+              <a:defRPr sz="1200" b="0">
+                <a:solidFill>
+                  <a:srgbClr val="2A2A2A"/>
+                </a:solidFill>
+                <a:latin typeface="Avenir Next"/>
+              </a:defRPr>
+            </a:pPr>
+            <a:r>
+              <a:rPr sz="1400" dirty="0">
+                <a:latin typeface="Avenir Next" panose="020B0503020202020204" pitchFamily="34" charset="0"/>
+              </a:rPr>
+              <a:t>Build shared technical expertise on carbon accounting, offsets, lifecycle analysis, and ESG assurance.</a:t>
+            </a:r>
+          </a:p>
+        </p:txBody>
+      </p:sp>
+      <p:sp>
+        <p:nvSpPr>
+          <p:cNvPr id="26" name="Rounded Rectangle 25"/>
+          <p:cNvSpPr/>
+          <p:nvPr/>
+        </p:nvSpPr>
+        <p:spPr>
+          <a:xfrm>
+            <a:off x="1097280" y="4343019"/>
+            <a:ext cx="10012680" cy="1121343"/>
+          </a:xfrm>
+          <a:prstGeom prst="roundRect">
+            <a:avLst/>
+          </a:prstGeom>
+          <a:solidFill>
+            <a:srgbClr val="FFF6EA"/>
+          </a:solidFill>
+          <a:ln w="12700">
+            <a:solidFill>
+              <a:srgbClr val="E7C894"/>
+            </a:solidFill>
+          </a:ln>
+        </p:spPr>
+        <p:style>
+          <a:lnRef idx="1">
+            <a:schemeClr val="accent1"/>
+          </a:lnRef>
+          <a:fillRef idx="3">
+            <a:schemeClr val="accent1"/>
+          </a:fillRef>
+          <a:effectRef idx="2">
+            <a:schemeClr val="accent1"/>
+          </a:effectRef>
+          <a:fontRef idx="minor">
+            <a:schemeClr val="lt1"/>
+          </a:fontRef>
+        </p:style>
+        <p:txBody>
+          <a:bodyPr rtlCol="0" anchor="ctr"/>
+          <a:lstStyle/>
+          <a:p>
+            <a:pPr algn="ctr"/>
+            <a:endParaRPr sz="2000">
+              <a:latin typeface="Avenir Next" panose="020B0503020202020204" pitchFamily="34" charset="0"/>
+            </a:endParaRPr>
+          </a:p>
+        </p:txBody>
+      </p:sp>
+      <p:sp>
+        <p:nvSpPr>
+          <p:cNvPr id="27" name="TextBox 26"/>
+          <p:cNvSpPr txBox="1"/>
+          <p:nvPr/>
+        </p:nvSpPr>
+        <p:spPr>
+          <a:xfrm>
+            <a:off x="1353312" y="4580764"/>
+            <a:ext cx="9509760" cy="707886"/>
+          </a:xfrm>
+          <a:prstGeom prst="rect">
+            <a:avLst/>
+          </a:prstGeom>
+          <a:noFill/>
+        </p:spPr>
+        <p:txBody>
+          <a:bodyPr wrap="square" anchor="t">
+            <a:spAutoFit/>
+          </a:bodyPr>
+          <a:lstStyle/>
+          <a:p>
+            <a:pPr algn="ctr">
+              <a:defRPr sz="1800" b="0">
+                <a:solidFill>
+                  <a:srgbClr val="173F35"/>
+                </a:solidFill>
+                <a:latin typeface="Georgia"/>
+              </a:defRPr>
+            </a:pPr>
+            <a:r>
+              <a:rPr sz="2000" dirty="0">
+                <a:latin typeface="Avenir Next" panose="020B0503020202020204" pitchFamily="34" charset="0"/>
+              </a:rPr>
+              <a:t>Narrative takeaway: credible anti-greenwashing law starts before the claim is published, not after the complaint is filed.</a:t>
+            </a:r>
+          </a:p>
+        </p:txBody>
+      </p:sp>
+      <p:sp>
+        <p:nvSpPr>
+          <p:cNvPr id="28" name="TextBox 27"/>
+          <p:cNvSpPr txBox="1"/>
+          <p:nvPr/>
+        </p:nvSpPr>
+        <p:spPr>
+          <a:xfrm>
+            <a:off x="734355" y="6419873"/>
+            <a:ext cx="1596912" cy="246221"/>
+          </a:xfrm>
+          <a:prstGeom prst="rect">
+            <a:avLst/>
+          </a:prstGeom>
+          <a:noFill/>
+        </p:spPr>
+        <p:txBody>
+          <a:bodyPr wrap="none">
+            <a:spAutoFit/>
+          </a:bodyPr>
+          <a:lstStyle/>
+          <a:p>
+            <a:pPr>
+              <a:defRPr sz="850">
+                <a:solidFill>
+                  <a:srgbClr val="6B6F6A"/>
+                </a:solidFill>
+                <a:latin typeface="Avenir Next"/>
+              </a:defRPr>
+            </a:pPr>
+            <a:r>
+              <a:rPr sz="1000" dirty="0"/>
+              <a:t>Source base: Chapter 6</a:t>
+            </a:r>
+            <a:r>
+              <a:rPr lang="en-US" sz="1000" dirty="0"/>
+              <a:t>.</a:t>
+            </a:r>
+            <a:endParaRPr sz="1000" dirty="0"/>
+          </a:p>
+        </p:txBody>
+      </p:sp>
+    </p:spTree>
+    <p:extLst>
+      <p:ext uri="{BB962C8B-B14F-4D97-AF65-F5344CB8AC3E}">
+        <p14:creationId xmlns:p14="http://schemas.microsoft.com/office/powerpoint/2010/main" val="918971880"/>
+      </p:ext>
+    </p:extLst>
+  </p:cSld>
+  <p:clrMapOvr>
+    <a:masterClrMapping/>
+  </p:clrMapOvr>
+</p:sld>
+</file>
+
+<file path=ppt/slides/slide23.xml><?xml version="1.0" encoding="utf-8"?>
+<p:sld xmlns:a="http://schemas.openxmlformats.org/drawingml/2006/main" xmlns:r="http://schemas.openxmlformats.org/officeDocument/2006/relationships" xmlns:p="http://schemas.openxmlformats.org/presentationml/2006/main">
+  <p:cSld>
+    <p:spTree>
+      <p:nvGrpSpPr>
+        <p:cNvPr id="1" name=""/>
+        <p:cNvGrpSpPr/>
+        <p:nvPr/>
+      </p:nvGrpSpPr>
+      <p:grpSpPr>
+        <a:xfrm>
+          <a:off x="0" y="0"/>
+          <a:ext cx="0" cy="0"/>
+          <a:chOff x="0" y="0"/>
+          <a:chExt cx="0" cy="0"/>
+        </a:xfrm>
+      </p:grpSpPr>
+      <p:sp>
+        <p:nvSpPr>
+          <p:cNvPr id="3" name="Rectangle 2"/>
+          <p:cNvSpPr/>
+          <p:nvPr/>
+        </p:nvSpPr>
+        <p:spPr>
+          <a:xfrm>
+            <a:off x="0" y="0"/>
+            <a:ext cx="12191695" cy="201168"/>
+          </a:xfrm>
+          <a:prstGeom prst="rect">
+            <a:avLst/>
+          </a:prstGeom>
+          <a:solidFill>
+            <a:srgbClr val="173F35"/>
+          </a:solidFill>
+          <a:ln>
+            <a:noFill/>
+          </a:ln>
+        </p:spPr>
+        <p:style>
+          <a:lnRef idx="1">
+            <a:schemeClr val="accent1"/>
+          </a:lnRef>
+          <a:fillRef idx="3">
+            <a:schemeClr val="accent1"/>
+          </a:fillRef>
+          <a:effectRef idx="2">
+            <a:schemeClr val="accent1"/>
+          </a:effectRef>
+          <a:fontRef idx="minor">
+            <a:schemeClr val="lt1"/>
+          </a:fontRef>
+        </p:style>
+        <p:txBody>
+          <a:bodyPr rtlCol="0" anchor="ctr"/>
+          <a:lstStyle/>
+          <a:p>
+            <a:pPr algn="ctr"/>
+            <a:endParaRPr/>
+          </a:p>
+        </p:txBody>
+      </p:sp>
+      <p:sp>
+        <p:nvSpPr>
+          <p:cNvPr id="4" name="TextBox 3"/>
+          <p:cNvSpPr txBox="1"/>
+          <p:nvPr/>
+        </p:nvSpPr>
+        <p:spPr>
+          <a:xfrm>
+            <a:off x="548639" y="384048"/>
             <a:ext cx="9380971" cy="584775"/>
           </a:xfrm>
           <a:prstGeom prst="rect">
@@ -20604,7 +21831,7 @@
 </p:sld>
 </file>
 
-<file path=ppt/slides/slide23.xml><?xml version="1.0" encoding="utf-8"?>
+<file path=ppt/slides/slide24.xml><?xml version="1.0" encoding="utf-8"?>
 <p:sld xmlns:a="http://schemas.openxmlformats.org/drawingml/2006/main" xmlns:r="http://schemas.openxmlformats.org/officeDocument/2006/relationships" xmlns:p="http://schemas.openxmlformats.org/presentationml/2006/main">
   <p:cSld>
     <p:spTree>

</xml_diff>

<commit_message>
docs: update thesis defence presentation slides
</commit_message>
<xml_diff>
--- a/Thesis Defence Presentation.pptx
+++ b/Thesis Defence Presentation.pptx
@@ -17599,14 +17599,14 @@
           <p:nvPr>
             <p:extLst>
               <p:ext uri="{D42A27DB-BD31-4B8C-83A1-F6EECF244321}">
-                <p14:modId xmlns:p14="http://schemas.microsoft.com/office/powerpoint/2010/main" val="2181829430"/>
+                <p14:modId xmlns:p14="http://schemas.microsoft.com/office/powerpoint/2010/main" val="166564843"/>
               </p:ext>
             </p:extLst>
           </p:nvPr>
         </p:nvGraphicFramePr>
         <p:xfrm>
           <a:off x="377059" y="943552"/>
-          <a:ext cx="11407110" cy="5534447"/>
+          <a:ext cx="11407110" cy="5854485"/>
         </p:xfrm>
         <a:graphic>
           <a:graphicData uri="http://schemas.openxmlformats.org/drawingml/2006/table">
@@ -17700,6 +17700,15 @@
                     <a:lstStyle/>
                     <a:p>
                       <a:pPr algn="l"/>
+                      <a:r>
+                        <a:rPr lang="en-US" sz="1100" b="1" dirty="0">
+                          <a:solidFill>
+                            <a:srgbClr val="FFFFFF"/>
+                          </a:solidFill>
+                          <a:latin typeface="Avenir Next"/>
+                        </a:rPr>
+                        <a:t>Related </a:t>
+                      </a:r>
                       <a:r>
                         <a:rPr sz="1100" b="1" dirty="0">
                           <a:solidFill>
@@ -17804,7 +17813,7 @@
                     <a:p>
                       <a:pPr algn="l"/>
                       <a:r>
-                        <a:rPr sz="950">
+                        <a:rPr sz="1050" dirty="0">
                           <a:solidFill>
                             <a:srgbClr val="3A3A4A"/>
                           </a:solidFill>
@@ -17827,7 +17836,7 @@
                     <a:p>
                       <a:pPr algn="l"/>
                       <a:r>
-                        <a:rPr sz="1000" b="1">
+                        <a:rPr sz="1100" b="1">
                           <a:solidFill>
                             <a:srgbClr val="095E4F"/>
                           </a:solidFill>
@@ -17836,23 +17845,14 @@
                         <a:t>Chapter 2</a:t>
                       </a:r>
                       <a:r>
-                        <a:rPr sz="950" b="0">
+                        <a:rPr sz="1050" b="0">
                           <a:solidFill>
                             <a:srgbClr val="3A3A4A"/>
                           </a:solidFill>
                           <a:latin typeface="Avenir Next"/>
                         </a:rPr>
                         <a:t> (Sec 2.1–2.5)
-</a:t>
-                      </a:r>
-                      <a:r>
-                        <a:rPr sz="900" b="0">
-                          <a:solidFill>
-                            <a:srgbClr val="3A3A4A"/>
-                          </a:solidFill>
-                          <a:latin typeface="Avenir Next"/>
-                        </a:rPr>
-                        <a:t>Evolution, Typology (Product/Corp/ESG), Harms &amp; Empirical Evidence</a:t>
+Evolution, Typology (Product/Corp/ESG), Harms &amp; Empirical Evidence</a:t>
                       </a:r>
                     </a:p>
                   </a:txBody>
@@ -17869,13 +17869,67 @@
                     <a:p>
                       <a:pPr algn="l"/>
                       <a:r>
-                        <a:rPr sz="950">
+                        <a:rPr sz="1050" dirty="0">
                           <a:solidFill>
                             <a:srgbClr val="3A3A4A"/>
                           </a:solidFill>
                           <a:latin typeface="Avenir Next"/>
                         </a:rPr>
-                        <a:t>It has moved from the product label to the balance sheet. The harm is misdirected capital, weaker market integrity and delayed climate action, not only a misled shopper.</a:t>
+                        <a:t>It has moved from the product label to the </a:t>
+                      </a:r>
+                      <a:r>
+                        <a:rPr lang="en-US" sz="1050" dirty="0">
+                          <a:solidFill>
+                            <a:srgbClr val="3A3A4A"/>
+                          </a:solidFill>
+                          <a:latin typeface="Avenir Next"/>
+                        </a:rPr>
+                        <a:t>ESG disclosures</a:t>
+                      </a:r>
+                      <a:r>
+                        <a:rPr sz="1050" dirty="0">
+                          <a:solidFill>
+                            <a:srgbClr val="3A3A4A"/>
+                          </a:solidFill>
+                          <a:latin typeface="Avenir Next"/>
+                        </a:rPr>
+                        <a:t>. The </a:t>
+                      </a:r>
+                      <a:r>
+                        <a:rPr lang="en-US" sz="1050" dirty="0">
+                          <a:solidFill>
+                            <a:srgbClr val="3A3A4A"/>
+                          </a:solidFill>
+                          <a:latin typeface="Avenir Next"/>
+                        </a:rPr>
+                        <a:t>consequences are: </a:t>
+                      </a:r>
+                      <a:r>
+                        <a:rPr sz="1050" dirty="0">
+                          <a:solidFill>
+                            <a:srgbClr val="3A3A4A"/>
+                          </a:solidFill>
+                          <a:latin typeface="Avenir Next"/>
+                        </a:rPr>
+                        <a:t>misdirected capital, weaker market integrity and delayed climate action, not only a </a:t>
+                      </a:r>
+                      <a:r>
+                        <a:rPr lang="en-US" sz="1050" dirty="0">
+                          <a:solidFill>
+                            <a:srgbClr val="3A3A4A"/>
+                          </a:solidFill>
+                          <a:latin typeface="Avenir Next"/>
+                        </a:rPr>
+                        <a:t>misguided </a:t>
+                      </a:r>
+                      <a:r>
+                        <a:rPr sz="1050" dirty="0">
+                          <a:solidFill>
+                            <a:srgbClr val="3A3A4A"/>
+                          </a:solidFill>
+                          <a:latin typeface="Avenir Next"/>
+                        </a:rPr>
+                        <a:t>shopper.</a:t>
                       </a:r>
                     </a:p>
                   </a:txBody>
@@ -17922,7 +17976,7 @@
                     <a:p>
                       <a:pPr algn="l"/>
                       <a:r>
-                        <a:rPr sz="950">
+                        <a:rPr sz="1050" dirty="0">
                           <a:solidFill>
                             <a:srgbClr val="3A3A4A"/>
                           </a:solidFill>
@@ -17945,7 +17999,7 @@
                     <a:p>
                       <a:pPr algn="l"/>
                       <a:r>
-                        <a:rPr sz="1000" b="1">
+                        <a:rPr sz="1100" b="1">
                           <a:solidFill>
                             <a:srgbClr val="095E4F"/>
                           </a:solidFill>
@@ -17954,7 +18008,7 @@
                         <a:t>Chapter 2</a:t>
                       </a:r>
                       <a:r>
-                        <a:rPr sz="950" b="0">
+                        <a:rPr sz="1050" b="0">
                           <a:solidFill>
                             <a:srgbClr val="3A3A4A"/>
                           </a:solidFill>
@@ -17963,7 +18017,7 @@
                         <a:t> (Sec 2.6) &amp; </a:t>
                       </a:r>
                       <a:r>
-                        <a:rPr sz="1000" b="1">
+                        <a:rPr sz="1100" b="1">
                           <a:solidFill>
                             <a:srgbClr val="095E4F"/>
                           </a:solidFill>
@@ -17972,23 +18026,14 @@
                         <a:t>Chapter 5</a:t>
                       </a:r>
                       <a:r>
-                        <a:rPr sz="950" b="0">
+                        <a:rPr sz="1050" b="0">
                           <a:solidFill>
                             <a:srgbClr val="3A3A4A"/>
                           </a:solidFill>
                           <a:latin typeface="Avenir Next"/>
                         </a:rPr>
                         <a:t> (Sec 5.2.1)
-</a:t>
-                      </a:r>
-                      <a:r>
-                        <a:rPr sz="900" b="0">
-                          <a:solidFill>
-                            <a:srgbClr val="3A3A4A"/>
-                          </a:solidFill>
-                          <a:latin typeface="Avenir Next"/>
-                        </a:rPr>
-                        <a:t>Limits of CPA 2019 / CCPA 2024 Guidelines &amp; Case for Governance Intervention</a:t>
+Limits of CPA 2019 / CCPA 2024 Guidelines &amp; Case for Governance Intervention</a:t>
                       </a:r>
                     </a:p>
                   </a:txBody>
@@ -18005,13 +18050,22 @@
                     <a:p>
                       <a:pPr algn="l"/>
                       <a:r>
-                        <a:rPr sz="950">
+                        <a:rPr lang="en-US" sz="1050" dirty="0">
                           <a:solidFill>
                             <a:srgbClr val="3A3A4A"/>
                           </a:solidFill>
                           <a:latin typeface="Avenir Next"/>
                         </a:rPr>
-                        <a:t>That law only reaches the claim after it is published. Company law reaches the board, the disclosure and the assurance that produced the claim.</a:t>
+                        <a:t>Consumer Protection </a:t>
+                      </a:r>
+                      <a:r>
+                        <a:rPr sz="1050" dirty="0">
+                          <a:solidFill>
+                            <a:srgbClr val="3A3A4A"/>
+                          </a:solidFill>
+                          <a:latin typeface="Avenir Next"/>
+                        </a:rPr>
+                        <a:t>law only reaches the claim after it is published. Company law reaches the board, the disclosure and the assurance that produced the claim.</a:t>
                       </a:r>
                     </a:p>
                   </a:txBody>
@@ -18058,7 +18112,7 @@
                     <a:p>
                       <a:pPr algn="l"/>
                       <a:r>
-                        <a:rPr sz="950">
+                        <a:rPr sz="1050">
                           <a:solidFill>
                             <a:srgbClr val="3A3A4A"/>
                           </a:solidFill>
@@ -18081,7 +18135,7 @@
                     <a:p>
                       <a:pPr algn="l"/>
                       <a:r>
-                        <a:rPr sz="1000" b="1">
+                        <a:rPr sz="1100" b="1" dirty="0">
                           <a:solidFill>
                             <a:srgbClr val="095E4F"/>
                           </a:solidFill>
@@ -18090,23 +18144,14 @@
                         <a:t>Chapter 3</a:t>
                       </a:r>
                       <a:r>
-                        <a:rPr sz="950" b="0">
+                        <a:rPr sz="1050" b="0" dirty="0">
                           <a:solidFill>
                             <a:srgbClr val="3A3A4A"/>
                           </a:solidFill>
                           <a:latin typeface="Avenir Next"/>
                         </a:rPr>
                         <a:t> (Sec 3.1–3.4)
-</a:t>
-                      </a:r>
-                      <a:r>
-                        <a:rPr sz="900" b="0">
-                          <a:solidFill>
-                            <a:srgbClr val="3A3A4A"/>
-                          </a:solidFill>
-                          <a:latin typeface="Avenir Next"/>
-                        </a:rPr>
-                        <a:t>Corporate Personality Theories, Hohfeldian Rights–Duties Analysis &amp; Agency Theory</a:t>
+Corporate Personality Theories, Hohfeldian Rights–Duties Analysis &amp; Agency Theory</a:t>
                       </a:r>
                     </a:p>
                   </a:txBody>
@@ -18123,13 +18168,31 @@
                     <a:p>
                       <a:pPr algn="l"/>
                       <a:r>
-                        <a:rPr sz="950">
+                        <a:rPr sz="1050" dirty="0">
                           <a:solidFill>
                             <a:srgbClr val="3A3A4A"/>
                           </a:solidFill>
                           <a:latin typeface="Avenir Next"/>
                         </a:rPr>
-                        <a:t>Read through Hohfeld, greenwashing is a breached duty, a misused managerial freedom and an exploited information advantage.</a:t>
+                        <a:t>Read through Hohfeld</a:t>
+                      </a:r>
+                      <a:r>
+                        <a:rPr lang="en-US" sz="1050" dirty="0">
+                          <a:solidFill>
+                            <a:srgbClr val="3A3A4A"/>
+                          </a:solidFill>
+                          <a:latin typeface="Avenir Next"/>
+                        </a:rPr>
+                        <a:t>ian Analysis</a:t>
+                      </a:r>
+                      <a:r>
+                        <a:rPr sz="1050" dirty="0">
+                          <a:solidFill>
+                            <a:srgbClr val="3A3A4A"/>
+                          </a:solidFill>
+                          <a:latin typeface="Avenir Next"/>
+                        </a:rPr>
+                        <a:t>, greenwashing is a breached duty, a misused managerial freedom and an exploited information advantage.</a:t>
                       </a:r>
                     </a:p>
                   </a:txBody>
@@ -18176,7 +18239,7 @@
                     <a:p>
                       <a:pPr algn="l"/>
                       <a:r>
-                        <a:rPr sz="950">
+                        <a:rPr sz="1050">
                           <a:solidFill>
                             <a:srgbClr val="3A3A4A"/>
                           </a:solidFill>
@@ -18199,7 +18262,7 @@
                     <a:p>
                       <a:pPr algn="l"/>
                       <a:r>
-                        <a:rPr sz="1000" b="1">
+                        <a:rPr sz="1100" b="1" dirty="0">
                           <a:solidFill>
                             <a:srgbClr val="095E4F"/>
                           </a:solidFill>
@@ -18208,7 +18271,7 @@
                         <a:t>Chapter 3</a:t>
                       </a:r>
                       <a:r>
-                        <a:rPr sz="950" b="0">
+                        <a:rPr sz="1050" b="0" dirty="0">
                           <a:solidFill>
                             <a:srgbClr val="3A3A4A"/>
                           </a:solidFill>
@@ -18217,7 +18280,7 @@
                         <a:t> (Sec 3.5–3.6) &amp; </a:t>
                       </a:r>
                       <a:r>
-                        <a:rPr sz="1000" b="1">
+                        <a:rPr sz="1100" b="1" dirty="0">
                           <a:solidFill>
                             <a:srgbClr val="095E4F"/>
                           </a:solidFill>
@@ -18226,23 +18289,14 @@
                         <a:t>Chapter 5</a:t>
                       </a:r>
                       <a:r>
-                        <a:rPr sz="950" b="0">
+                        <a:rPr sz="1050" b="0" dirty="0">
                           <a:solidFill>
                             <a:srgbClr val="3A3A4A"/>
                           </a:solidFill>
                           <a:latin typeface="Avenir Next"/>
                         </a:rPr>
                         <a:t> (Sec 5.2.2–5.2.3)
-</a:t>
-                      </a:r>
-                      <a:r>
-                        <a:rPr sz="900" b="0">
-                          <a:solidFill>
-                            <a:srgbClr val="3A3A4A"/>
-                          </a:solidFill>
-                          <a:latin typeface="Avenir Next"/>
-                        </a:rPr>
-                        <a:t>Section 166(2) Fiduciary Duty, SEBI BRSR / BRSR Core, PFUTP &amp; MCA Framework</a:t>
+Section 166(2) Fiduciary Duty, SEBI BRSR / BRSR Core, PFUTP &amp; MCA Framework</a:t>
                       </a:r>
                     </a:p>
                   </a:txBody>
@@ -18259,13 +18313,31 @@
                     <a:p>
                       <a:pPr algn="l"/>
                       <a:r>
-                        <a:rPr sz="950">
+                        <a:rPr sz="1050" dirty="0">
                           <a:solidFill>
                             <a:srgbClr val="3A3A4A"/>
                           </a:solidFill>
                           <a:latin typeface="Avenir Next"/>
                         </a:rPr>
-                        <a:t>Section 166(2), SEBI's BRSR and BRSR Core, and PFUTP already exist. Narrow standing, small penalties and softened assurance stop them from being triggered.</a:t>
+                        <a:t>Section 166(2), SEBI's BRSR and BRSR Core, and PFUTP already exist. </a:t>
+                      </a:r>
+                      <a:r>
+                        <a:rPr lang="en-US" sz="1050" dirty="0">
+                          <a:solidFill>
+                            <a:srgbClr val="3A3A4A"/>
+                          </a:solidFill>
+                          <a:latin typeface="Avenir Next"/>
+                        </a:rPr>
+                        <a:t>But they suffer from n</a:t>
+                      </a:r>
+                      <a:r>
+                        <a:rPr sz="1050" dirty="0">
+                          <a:solidFill>
+                            <a:srgbClr val="3A3A4A"/>
+                          </a:solidFill>
+                          <a:latin typeface="Avenir Next"/>
+                        </a:rPr>
+                        <a:t>arrow standing, small penalties and softened assurance stop them from being triggered.</a:t>
                       </a:r>
                     </a:p>
                   </a:txBody>
@@ -18312,7 +18384,7 @@
                     <a:p>
                       <a:pPr algn="l"/>
                       <a:r>
-                        <a:rPr sz="950">
+                        <a:rPr sz="1050">
                           <a:solidFill>
                             <a:srgbClr val="3A3A4A"/>
                           </a:solidFill>
@@ -18335,7 +18407,7 @@
                     <a:p>
                       <a:pPr algn="l"/>
                       <a:r>
-                        <a:rPr sz="1000" b="1">
+                        <a:rPr sz="1100" b="1" dirty="0">
                           <a:solidFill>
                             <a:srgbClr val="095E4F"/>
                           </a:solidFill>
@@ -18344,23 +18416,14 @@
                         <a:t>Chapter 4</a:t>
                       </a:r>
                       <a:r>
-                        <a:rPr sz="950" b="0">
+                        <a:rPr sz="1050" b="0" dirty="0">
                           <a:solidFill>
                             <a:srgbClr val="3A3A4A"/>
                           </a:solidFill>
                           <a:latin typeface="Avenir Next"/>
                         </a:rPr>
                         <a:t> (Sec 4.1–4.8, 4.10)
-</a:t>
-                      </a:r>
-                      <a:r>
-                        <a:rPr sz="900" b="0">
-                          <a:solidFill>
-                            <a:srgbClr val="3A3A4A"/>
-                          </a:solidFill>
-                          <a:latin typeface="Avenir Next"/>
-                        </a:rPr>
-                        <a:t>International Standards (ISO/UN/IOSCO), Global Regimes (EU/UK/US/Aus) &amp; 10 Design Levers</a:t>
+International Standards (ISO/UN/IOSCO), Global Regimes (EU/UK/US/Aus) &amp; 10 Design Levers</a:t>
                       </a:r>
                     </a:p>
                   </a:txBody>
@@ -18377,7 +18440,7 @@
                     <a:p>
                       <a:pPr algn="l"/>
                       <a:r>
-                        <a:rPr sz="950">
+                        <a:rPr sz="1050" dirty="0">
                           <a:solidFill>
                             <a:srgbClr val="3A3A4A"/>
                           </a:solidFill>
@@ -18430,7 +18493,7 @@
                     <a:p>
                       <a:pPr algn="l"/>
                       <a:r>
-                        <a:rPr sz="950">
+                        <a:rPr sz="1050">
                           <a:solidFill>
                             <a:srgbClr val="3A3A4A"/>
                           </a:solidFill>
@@ -18453,7 +18516,7 @@
                     <a:p>
                       <a:pPr algn="l"/>
                       <a:r>
-                        <a:rPr sz="1000" b="1">
+                        <a:rPr sz="1100" b="1">
                           <a:solidFill>
                             <a:srgbClr val="095E4F"/>
                           </a:solidFill>
@@ -18462,23 +18525,14 @@
                         <a:t>Chapter 5</a:t>
                       </a:r>
                       <a:r>
-                        <a:rPr sz="950" b="0">
+                        <a:rPr sz="1050" b="0">
                           <a:solidFill>
                             <a:srgbClr val="3A3A4A"/>
                           </a:solidFill>
                           <a:latin typeface="Avenir Next"/>
                         </a:rPr>
                         <a:t> (Sec 5.1–5.4)
-</a:t>
-                      </a:r>
-                      <a:r>
-                        <a:rPr sz="900" b="0">
-                          <a:solidFill>
-                            <a:srgbClr val="3A3A4A"/>
-                          </a:solidFill>
-                          <a:latin typeface="Avenir Next"/>
-                        </a:rPr>
-                        <a:t>Indian Regulatory Ecosystem &amp; 5 Systemic Gaps (Fragmentation, Arbitrage, Backsliding)</a:t>
+Indian Regulatory Ecosystem &amp; 5 Systemic Gaps (Fragmentation, Arbitrage, Backsliding)</a:t>
                       </a:r>
                     </a:p>
                   </a:txBody>
@@ -18495,13 +18549,31 @@
                     <a:p>
                       <a:pPr algn="l"/>
                       <a:r>
-                        <a:rPr sz="950">
+                        <a:rPr sz="1050" dirty="0">
                           <a:solidFill>
                             <a:srgbClr val="3A3A4A"/>
                           </a:solidFill>
                           <a:latin typeface="Avenir Next"/>
                         </a:rPr>
-                        <a:t>Five structural gaps: fragmented definitions, unharmonised proliferation, active backsliding, reactive enforcement and penalty arbitrage.</a:t>
+                        <a:t>Five structural gaps: fragmented definitions, </a:t>
+                      </a:r>
+                      <a:r>
+                        <a:rPr sz="1050" dirty="0" err="1">
+                          <a:solidFill>
+                            <a:srgbClr val="3A3A4A"/>
+                          </a:solidFill>
+                          <a:latin typeface="Avenir Next"/>
+                        </a:rPr>
+                        <a:t>unharmonised</a:t>
+                      </a:r>
+                      <a:r>
+                        <a:rPr sz="1050" dirty="0">
+                          <a:solidFill>
+                            <a:srgbClr val="3A3A4A"/>
+                          </a:solidFill>
+                          <a:latin typeface="Avenir Next"/>
+                        </a:rPr>
+                        <a:t> proliferation, active backsliding, reactive enforcement and penalty arbitrage.</a:t>
                       </a:r>
                     </a:p>
                   </a:txBody>
@@ -18548,7 +18620,7 @@
                     <a:p>
                       <a:pPr algn="l"/>
                       <a:r>
-                        <a:rPr sz="950">
+                        <a:rPr sz="1050">
                           <a:solidFill>
                             <a:srgbClr val="3A3A4A"/>
                           </a:solidFill>
@@ -18571,7 +18643,7 @@
                     <a:p>
                       <a:pPr algn="l"/>
                       <a:r>
-                        <a:rPr sz="1000" b="1">
+                        <a:rPr sz="1100" b="1">
                           <a:solidFill>
                             <a:srgbClr val="095E4F"/>
                           </a:solidFill>
@@ -18580,23 +18652,14 @@
                         <a:t>Chapter 6</a:t>
                       </a:r>
                       <a:r>
-                        <a:rPr sz="950" b="0">
+                        <a:rPr sz="1050" b="0">
                           <a:solidFill>
                             <a:srgbClr val="3A3A4A"/>
                           </a:solidFill>
                           <a:latin typeface="Avenir Next"/>
                         </a:rPr>
                         <a:t> (Sec 6.1–6.3)
-</a:t>
-                      </a:r>
-                      <a:r>
-                        <a:rPr sz="900" b="0">
-                          <a:solidFill>
-                            <a:srgbClr val="3A3A4A"/>
-                          </a:solidFill>
-                          <a:latin typeface="Avenir Next"/>
-                        </a:rPr>
-                        <a:t>Synthesis of Findings, Hypothesis Testing &amp; Integrated 5-Level Statutory/Regulatory Reforms</a:t>
+Synthesis of Findings, Hypothesis Testing &amp; Integrated 5-Level Statutory/Regulatory Reforms</a:t>
                       </a:r>
                     </a:p>
                   </a:txBody>
@@ -18613,7 +18676,7 @@
                     <a:p>
                       <a:pPr algn="l"/>
                       <a:r>
-                        <a:rPr sz="950" dirty="0">
+                        <a:rPr sz="1050" dirty="0">
                           <a:solidFill>
                             <a:srgbClr val="3A3A4A"/>
                           </a:solidFill>
@@ -19405,25 +19468,7 @@
                 </a:solidFill>
                 <a:latin typeface="Avenir Next" panose="020B0503020202020204" pitchFamily="34" charset="0"/>
               </a:rPr>
-              <a:t>Detection is fragmented; weak verification raises proof burdens. </a:t>
-            </a:r>
-            <a:r>
-              <a:rPr sz="1100" dirty="0" err="1">
-                <a:solidFill>
-                  <a:srgbClr val="2A2A2A"/>
-                </a:solidFill>
-                <a:latin typeface="Avenir Next" panose="020B0503020202020204" pitchFamily="34" charset="0"/>
-              </a:rPr>
-              <a:t>Hohfeldian</a:t>
-            </a:r>
-            <a:r>
-              <a:rPr sz="1100" dirty="0">
-                <a:solidFill>
-                  <a:srgbClr val="2A2A2A"/>
-                </a:solidFill>
-                <a:latin typeface="Avenir Next" panose="020B0503020202020204" pitchFamily="34" charset="0"/>
-              </a:rPr>
-              <a:t> analysis: legal duties without accessible triggers fail to create real liability.</a:t>
+              <a:t>Detection is fragmented; weak verification raises proof burdens. Hohfeldian analysis: legal duties without accessible triggers fail to create real liability.</a:t>
             </a:r>
           </a:p>
           <a:p>
@@ -26334,16 +26379,10 @@
               </a:defRPr>
             </a:pPr>
             <a:r>
-              <a:rPr sz="1200" dirty="0" err="1">
-                <a:latin typeface="Avenir Next" panose="020B0503020202020204" pitchFamily="34" charset="0"/>
-              </a:rPr>
-              <a:t>Hohfeldian</a:t>
-            </a:r>
-            <a:r>
               <a:rPr sz="1200" dirty="0">
                 <a:latin typeface="Avenir Next" panose="020B0503020202020204" pitchFamily="34" charset="0"/>
               </a:rPr>
-              <a:t> decomposition of corporate duties into precise legal relations. </a:t>
+              <a:t>Hohfeldian decomposition of corporate duties into precise legal relations. </a:t>
             </a:r>
             <a:endParaRPr lang="en-US" sz="1200" dirty="0">
               <a:latin typeface="Avenir Next" panose="020B0503020202020204" pitchFamily="34" charset="0"/>

</xml_diff>